<commit_message>
Day3 g2_skin_screening: polish deck — embed all 7 figures, big-stat melanoma recall, speaker notes
</commit_message>
<xml_diff>
--- a/solutions/g2_skin_screening/slides/g2_skin_screening.pptx
+++ b/solutions/g2_skin_screening/slides/g2_skin_screening.pptx
@@ -7,22 +7,22 @@
   <p:sldIdLst>
     <p:sldId id="256" r:id="rId7"/>
     <p:sldId id="257" r:id="rId8"/>
-    <p:sldId id="258" r:id="rId9"/>
-    <p:sldId id="259" r:id="rId10"/>
-    <p:sldId id="260" r:id="rId11"/>
-    <p:sldId id="261" r:id="rId12"/>
-    <p:sldId id="262" r:id="rId13"/>
-    <p:sldId id="263" r:id="rId14"/>
-    <p:sldId id="264" r:id="rId15"/>
-    <p:sldId id="265" r:id="rId16"/>
-    <p:sldId id="266" r:id="rId17"/>
-    <p:sldId id="267" r:id="rId18"/>
-    <p:sldId id="268" r:id="rId19"/>
-    <p:sldId id="269" r:id="rId20"/>
-    <p:sldId id="270" r:id="rId21"/>
-    <p:sldId id="271" r:id="rId22"/>
-    <p:sldId id="272" r:id="rId23"/>
-    <p:sldId id="273" r:id="rId24"/>
+    <p:sldId id="258" r:id="rId10"/>
+    <p:sldId id="259" r:id="rId11"/>
+    <p:sldId id="260" r:id="rId12"/>
+    <p:sldId id="261" r:id="rId13"/>
+    <p:sldId id="262" r:id="rId14"/>
+    <p:sldId id="263" r:id="rId15"/>
+    <p:sldId id="264" r:id="rId16"/>
+    <p:sldId id="265" r:id="rId17"/>
+    <p:sldId id="266" r:id="rId18"/>
+    <p:sldId id="267" r:id="rId19"/>
+    <p:sldId id="268" r:id="rId20"/>
+    <p:sldId id="269" r:id="rId21"/>
+    <p:sldId id="270" r:id="rId22"/>
+    <p:sldId id="271" r:id="rId23"/>
+    <p:sldId id="272" r:id="rId24"/>
+    <p:sldId id="273" r:id="rId25"/>
   </p:sldIdLst>
   <p:sldSz cx="12191695" cy="6858000" type="screen4x3"/>
   <p:notesSz cx="6858000" cy="9144000"/>
@@ -122,6 +122,1652 @@
     </a:lvl9pPr>
   </p:defaultTextStyle>
 </p:presentation>
+</file>
+
+<file path=ppt/notesMasters/notesMaster1.xml><?xml version="1.0" encoding="utf-8"?>
+<p:notesMaster xmlns:a="http://schemas.openxmlformats.org/drawingml/2006/main" xmlns:p="http://schemas.openxmlformats.org/presentationml/2006/main" xmlns:r="http://schemas.openxmlformats.org/officeDocument/2006/relationships">
+  <p:cSld>
+    <p:bg>
+      <p:bgRef idx="1001">
+        <a:schemeClr val="bg1"/>
+      </p:bgRef>
+    </p:bg>
+    <p:spTree>
+      <p:nvGrpSpPr>
+        <p:cNvPr id="1" name=""/>
+        <p:cNvGrpSpPr/>
+        <p:nvPr/>
+      </p:nvGrpSpPr>
+      <p:grpSpPr>
+        <a:xfrm>
+          <a:off x="0" y="0"/>
+          <a:ext cx="0" cy="0"/>
+          <a:chOff x="0" y="0"/>
+          <a:chExt cx="0" cy="0"/>
+        </a:xfrm>
+      </p:grpSpPr>
+      <p:sp>
+        <p:nvSpPr>
+          <p:cNvPr id="2" name="Header Placeholder 1"/>
+          <p:cNvSpPr>
+            <a:spLocks noGrp="1"/>
+          </p:cNvSpPr>
+          <p:nvPr>
+            <p:ph type="hdr" sz="quarter"/>
+          </p:nvPr>
+        </p:nvSpPr>
+        <p:spPr>
+          <a:xfrm>
+            <a:off x="0" y="0"/>
+            <a:ext cx="2971800" cy="457200"/>
+          </a:xfrm>
+          <a:prstGeom prst="rect">
+            <a:avLst/>
+          </a:prstGeom>
+        </p:spPr>
+        <p:txBody>
+          <a:bodyPr vert="horz" lIns="91440" tIns="45720" rIns="91440" bIns="45720" rtlCol="0"/>
+          <a:lstStyle>
+            <a:lvl1pPr algn="l">
+              <a:defRPr sz="1200"/>
+            </a:lvl1pPr>
+          </a:lstStyle>
+          <a:p>
+            <a:endParaRPr lang="en-US"/>
+          </a:p>
+        </p:txBody>
+      </p:sp>
+      <p:sp>
+        <p:nvSpPr>
+          <p:cNvPr id="3" name="Date Placeholder 2"/>
+          <p:cNvSpPr>
+            <a:spLocks noGrp="1"/>
+          </p:cNvSpPr>
+          <p:nvPr>
+            <p:ph type="dt" idx="1"/>
+          </p:nvPr>
+        </p:nvSpPr>
+        <p:spPr>
+          <a:xfrm>
+            <a:off x="3884613" y="0"/>
+            <a:ext cx="2971800" cy="457200"/>
+          </a:xfrm>
+          <a:prstGeom prst="rect">
+            <a:avLst/>
+          </a:prstGeom>
+        </p:spPr>
+        <p:txBody>
+          <a:bodyPr vert="horz" lIns="91440" tIns="45720" rIns="91440" bIns="45720" rtlCol="0"/>
+          <a:lstStyle>
+            <a:lvl1pPr algn="r">
+              <a:defRPr sz="1200"/>
+            </a:lvl1pPr>
+          </a:lstStyle>
+          <a:p>
+            <a:fld id="{0F89C1C7-3DCD-1040-A9CF-14679D8B5DDD}" type="datetimeFigureOut">
+              <a:rPr lang="en-US" smtClean="0"/>
+              <a:t>10/17/16</a:t>
+            </a:fld>
+            <a:endParaRPr lang="en-US"/>
+          </a:p>
+        </p:txBody>
+      </p:sp>
+      <p:sp>
+        <p:nvSpPr>
+          <p:cNvPr id="4" name="Slide Image Placeholder 3"/>
+          <p:cNvSpPr>
+            <a:spLocks noGrp="1" noRot="1" noChangeAspect="1"/>
+          </p:cNvSpPr>
+          <p:nvPr>
+            <p:ph type="sldImg" idx="2"/>
+          </p:nvPr>
+        </p:nvSpPr>
+        <p:spPr>
+          <a:xfrm>
+            <a:off x="1143000" y="685800"/>
+            <a:ext cx="4572000" cy="3429000"/>
+          </a:xfrm>
+          <a:prstGeom prst="rect">
+            <a:avLst/>
+          </a:prstGeom>
+          <a:noFill/>
+          <a:ln w="12700">
+            <a:solidFill>
+              <a:prstClr val="black"/>
+            </a:solidFill>
+          </a:ln>
+        </p:spPr>
+        <p:txBody>
+          <a:bodyPr vert="horz" lIns="91440" tIns="45720" rIns="91440" bIns="45720" rtlCol="0" anchor="ctr"/>
+          <a:lstStyle/>
+          <a:p>
+            <a:endParaRPr lang="en-US"/>
+          </a:p>
+        </p:txBody>
+      </p:sp>
+      <p:sp>
+        <p:nvSpPr>
+          <p:cNvPr id="5" name="Notes Placeholder 4"/>
+          <p:cNvSpPr>
+            <a:spLocks noGrp="1"/>
+          </p:cNvSpPr>
+          <p:nvPr>
+            <p:ph type="body" sz="quarter" idx="3"/>
+          </p:nvPr>
+        </p:nvSpPr>
+        <p:spPr>
+          <a:xfrm>
+            <a:off x="685800" y="4343400"/>
+            <a:ext cx="5486400" cy="4114800"/>
+          </a:xfrm>
+          <a:prstGeom prst="rect">
+            <a:avLst/>
+          </a:prstGeom>
+        </p:spPr>
+        <p:txBody>
+          <a:bodyPr vert="horz" lIns="91440" tIns="45720" rIns="91440" bIns="45720" rtlCol="0"/>
+          <a:lstStyle/>
+          <a:p>
+            <a:pPr lvl="0"/>
+            <a:r>
+              <a:rPr lang="en-US" smtClean="0"/>
+              <a:t>Click to edit Master text styles</a:t>
+            </a:r>
+          </a:p>
+          <a:p>
+            <a:pPr lvl="1"/>
+            <a:r>
+              <a:rPr lang="en-US" smtClean="0"/>
+              <a:t>Second level</a:t>
+            </a:r>
+          </a:p>
+          <a:p>
+            <a:pPr lvl="2"/>
+            <a:r>
+              <a:rPr lang="en-US" smtClean="0"/>
+              <a:t>Third level</a:t>
+            </a:r>
+          </a:p>
+          <a:p>
+            <a:pPr lvl="3"/>
+            <a:r>
+              <a:rPr lang="en-US" smtClean="0"/>
+              <a:t>Fourth level</a:t>
+            </a:r>
+          </a:p>
+          <a:p>
+            <a:pPr lvl="4"/>
+            <a:r>
+              <a:rPr lang="en-US" smtClean="0"/>
+              <a:t>Fifth level</a:t>
+            </a:r>
+            <a:endParaRPr lang="en-US"/>
+          </a:p>
+        </p:txBody>
+      </p:sp>
+      <p:sp>
+        <p:nvSpPr>
+          <p:cNvPr id="6" name="Footer Placeholder 5"/>
+          <p:cNvSpPr>
+            <a:spLocks noGrp="1"/>
+          </p:cNvSpPr>
+          <p:nvPr>
+            <p:ph type="ftr" sz="quarter" idx="4"/>
+          </p:nvPr>
+        </p:nvSpPr>
+        <p:spPr>
+          <a:xfrm>
+            <a:off x="0" y="8685213"/>
+            <a:ext cx="2971800" cy="457200"/>
+          </a:xfrm>
+          <a:prstGeom prst="rect">
+            <a:avLst/>
+          </a:prstGeom>
+        </p:spPr>
+        <p:txBody>
+          <a:bodyPr vert="horz" lIns="91440" tIns="45720" rIns="91440" bIns="45720" rtlCol="0" anchor="b"/>
+          <a:lstStyle>
+            <a:lvl1pPr algn="l">
+              <a:defRPr sz="1200"/>
+            </a:lvl1pPr>
+          </a:lstStyle>
+          <a:p>
+            <a:endParaRPr lang="en-US"/>
+          </a:p>
+        </p:txBody>
+      </p:sp>
+      <p:sp>
+        <p:nvSpPr>
+          <p:cNvPr id="7" name="Slide Number Placeholder 6"/>
+          <p:cNvSpPr>
+            <a:spLocks noGrp="1"/>
+          </p:cNvSpPr>
+          <p:nvPr>
+            <p:ph type="sldNum" sz="quarter" idx="5"/>
+          </p:nvPr>
+        </p:nvSpPr>
+        <p:spPr>
+          <a:xfrm>
+            <a:off x="3884613" y="8685213"/>
+            <a:ext cx="2971800" cy="457200"/>
+          </a:xfrm>
+          <a:prstGeom prst="rect">
+            <a:avLst/>
+          </a:prstGeom>
+        </p:spPr>
+        <p:txBody>
+          <a:bodyPr vert="horz" lIns="91440" tIns="45720" rIns="91440" bIns="45720" rtlCol="0" anchor="b"/>
+          <a:lstStyle>
+            <a:lvl1pPr algn="r">
+              <a:defRPr sz="1200"/>
+            </a:lvl1pPr>
+          </a:lstStyle>
+          <a:p>
+            <a:fld id="{BB5E49A5-4136-284D-997B-48E1D791AD67}" type="slidenum">
+              <a:rPr lang="en-US" smtClean="0"/>
+              <a:t>‹#›</a:t>
+            </a:fld>
+            <a:endParaRPr lang="en-US"/>
+          </a:p>
+        </p:txBody>
+      </p:sp>
+    </p:spTree>
+    <p:extLst>
+      <p:ext uri="{BB962C8B-B14F-4D97-AF65-F5344CB8AC3E}">
+        <p14:creationId xmlns:p14="http://schemas.microsoft.com/office/powerpoint/2010/main" val="2623252185"/>
+      </p:ext>
+    </p:extLst>
+  </p:cSld>
+  <p:clrMap bg1="lt1" tx1="dk1" bg2="lt2" tx2="dk2" accent1="accent1" accent2="accent2" accent3="accent3" accent4="accent4" accent5="accent5" accent6="accent6" hlink="hlink" folHlink="folHlink"/>
+  <p:notesStyle>
+    <a:lvl1pPr marL="0" algn="l" defTabSz="457200" rtl="0" eaLnBrk="1" latinLnBrk="0" hangingPunct="1">
+      <a:defRPr sz="1200" kern="1200">
+        <a:solidFill>
+          <a:schemeClr val="tx1"/>
+        </a:solidFill>
+        <a:latin typeface="+mn-lt"/>
+        <a:ea typeface="+mn-ea"/>
+        <a:cs typeface="+mn-cs"/>
+      </a:defRPr>
+    </a:lvl1pPr>
+    <a:lvl2pPr marL="457200" algn="l" defTabSz="457200" rtl="0" eaLnBrk="1" latinLnBrk="0" hangingPunct="1">
+      <a:defRPr sz="1200" kern="1200">
+        <a:solidFill>
+          <a:schemeClr val="tx1"/>
+        </a:solidFill>
+        <a:latin typeface="+mn-lt"/>
+        <a:ea typeface="+mn-ea"/>
+        <a:cs typeface="+mn-cs"/>
+      </a:defRPr>
+    </a:lvl2pPr>
+    <a:lvl3pPr marL="914400" algn="l" defTabSz="457200" rtl="0" eaLnBrk="1" latinLnBrk="0" hangingPunct="1">
+      <a:defRPr sz="1200" kern="1200">
+        <a:solidFill>
+          <a:schemeClr val="tx1"/>
+        </a:solidFill>
+        <a:latin typeface="+mn-lt"/>
+        <a:ea typeface="+mn-ea"/>
+        <a:cs typeface="+mn-cs"/>
+      </a:defRPr>
+    </a:lvl3pPr>
+    <a:lvl4pPr marL="1371600" algn="l" defTabSz="457200" rtl="0" eaLnBrk="1" latinLnBrk="0" hangingPunct="1">
+      <a:defRPr sz="1200" kern="1200">
+        <a:solidFill>
+          <a:schemeClr val="tx1"/>
+        </a:solidFill>
+        <a:latin typeface="+mn-lt"/>
+        <a:ea typeface="+mn-ea"/>
+        <a:cs typeface="+mn-cs"/>
+      </a:defRPr>
+    </a:lvl4pPr>
+    <a:lvl5pPr marL="1828800" algn="l" defTabSz="457200" rtl="0" eaLnBrk="1" latinLnBrk="0" hangingPunct="1">
+      <a:defRPr sz="1200" kern="1200">
+        <a:solidFill>
+          <a:schemeClr val="tx1"/>
+        </a:solidFill>
+        <a:latin typeface="+mn-lt"/>
+        <a:ea typeface="+mn-ea"/>
+        <a:cs typeface="+mn-cs"/>
+      </a:defRPr>
+    </a:lvl5pPr>
+    <a:lvl6pPr marL="2286000" algn="l" defTabSz="457200" rtl="0" eaLnBrk="1" latinLnBrk="0" hangingPunct="1">
+      <a:defRPr sz="1200" kern="1200">
+        <a:solidFill>
+          <a:schemeClr val="tx1"/>
+        </a:solidFill>
+        <a:latin typeface="+mn-lt"/>
+        <a:ea typeface="+mn-ea"/>
+        <a:cs typeface="+mn-cs"/>
+      </a:defRPr>
+    </a:lvl6pPr>
+    <a:lvl7pPr marL="2743200" algn="l" defTabSz="457200" rtl="0" eaLnBrk="1" latinLnBrk="0" hangingPunct="1">
+      <a:defRPr sz="1200" kern="1200">
+        <a:solidFill>
+          <a:schemeClr val="tx1"/>
+        </a:solidFill>
+        <a:latin typeface="+mn-lt"/>
+        <a:ea typeface="+mn-ea"/>
+        <a:cs typeface="+mn-cs"/>
+      </a:defRPr>
+    </a:lvl7pPr>
+    <a:lvl8pPr marL="3200400" algn="l" defTabSz="457200" rtl="0" eaLnBrk="1" latinLnBrk="0" hangingPunct="1">
+      <a:defRPr sz="1200" kern="1200">
+        <a:solidFill>
+          <a:schemeClr val="tx1"/>
+        </a:solidFill>
+        <a:latin typeface="+mn-lt"/>
+        <a:ea typeface="+mn-ea"/>
+        <a:cs typeface="+mn-cs"/>
+      </a:defRPr>
+    </a:lvl8pPr>
+    <a:lvl9pPr marL="3657600" algn="l" defTabSz="457200" rtl="0" eaLnBrk="1" latinLnBrk="0" hangingPunct="1">
+      <a:defRPr sz="1200" kern="1200">
+        <a:solidFill>
+          <a:schemeClr val="tx1"/>
+        </a:solidFill>
+        <a:latin typeface="+mn-lt"/>
+        <a:ea typeface="+mn-ea"/>
+        <a:cs typeface="+mn-cs"/>
+      </a:defRPr>
+    </a:lvl9pPr>
+  </p:notesStyle>
+</p:notesMaster>
+</file>
+
+<file path=ppt/notesSlides/notesSlide1.xml><?xml version="1.0" encoding="utf-8"?>
+<p:notes xmlns:a="http://schemas.openxmlformats.org/drawingml/2006/main" xmlns:p="http://schemas.openxmlformats.org/presentationml/2006/main" xmlns:r="http://schemas.openxmlformats.org/officeDocument/2006/relationships">
+  <p:cSld>
+    <p:spTree>
+      <p:nvGrpSpPr>
+        <p:cNvPr id="1" name=""/>
+        <p:cNvGrpSpPr/>
+        <p:nvPr/>
+      </p:nvGrpSpPr>
+      <p:grpSpPr>
+        <a:xfrm>
+          <a:off x="0" y="0"/>
+          <a:ext cx="0" cy="0"/>
+          <a:chOff x="0" y="0"/>
+          <a:chExt cx="0" cy="0"/>
+        </a:xfrm>
+      </p:grpSpPr>
+      <p:sp>
+        <p:nvSpPr>
+          <p:cNvPr id="2" name="Slide Image Placeholder 1"/>
+          <p:cNvSpPr>
+            <a:spLocks noGrp="1"/>
+          </p:cNvSpPr>
+          <p:nvPr>
+            <p:ph type="sldImg" idx="2"/>
+          </p:nvPr>
+        </p:nvSpPr>
+        <p:spPr/>
+      </p:sp>
+      <p:sp>
+        <p:nvSpPr>
+          <p:cNvPr id="3" name="Notes Placeholder 2"/>
+          <p:cNvSpPr>
+            <a:spLocks noGrp="1"/>
+          </p:cNvSpPr>
+          <p:nvPr>
+            <p:ph type="body" idx="3" sz="quarter"/>
+          </p:nvPr>
+        </p:nvSpPr>
+        <p:spPr/>
+        <p:txBody>
+          <a:bodyPr/>
+          <a:lstStyle/>
+          <a:p>
+            <a:r>
+              <a:rPr b="1" sz="1300">
+                <a:latin typeface="Geist Mono"/>
+              </a:rPr>
+              <a:t>Background</a:t>
+            </a:r>
+          </a:p>
+          <a:p>
+            <a:r>
+              <a:rPr b="0" sz="1100">
+                <a:latin typeface="Geist"/>
+              </a:rPr>
+              <a:t>This opening section sets up the problem: what a skin-screening model actually does, and why catching every melanoma matters more than raw accuracy. Keep the asymmetry of the two mistakes in mind throughout.</a:t>
+            </a:r>
+          </a:p>
+        </p:txBody>
+      </p:sp>
+      <p:sp>
+        <p:nvSpPr>
+          <p:cNvPr id="4" name="Slide Number Placeholder 3"/>
+          <p:cNvSpPr>
+            <a:spLocks noGrp="1"/>
+          </p:cNvSpPr>
+          <p:nvPr>
+            <p:ph type="sldNum" idx="5" sz="quarter"/>
+          </p:nvPr>
+        </p:nvSpPr>
+        <p:spPr/>
+      </p:sp>
+    </p:spTree>
+  </p:cSld>
+  <p:clrMapOvr>
+    <a:masterClrMapping/>
+  </p:clrMapOvr>
+</p:notes>
+</file>
+
+<file path=ppt/notesSlides/notesSlide10.xml><?xml version="1.0" encoding="utf-8"?>
+<p:notes xmlns:a="http://schemas.openxmlformats.org/drawingml/2006/main" xmlns:p="http://schemas.openxmlformats.org/presentationml/2006/main" xmlns:r="http://schemas.openxmlformats.org/officeDocument/2006/relationships">
+  <p:cSld>
+    <p:spTree>
+      <p:nvGrpSpPr>
+        <p:cNvPr id="1" name=""/>
+        <p:cNvGrpSpPr/>
+        <p:nvPr/>
+      </p:nvGrpSpPr>
+      <p:grpSpPr>
+        <a:xfrm>
+          <a:off x="0" y="0"/>
+          <a:ext cx="0" cy="0"/>
+          <a:chOff x="0" y="0"/>
+          <a:chExt cx="0" cy="0"/>
+        </a:xfrm>
+      </p:grpSpPr>
+      <p:sp>
+        <p:nvSpPr>
+          <p:cNvPr id="2" name="Slide Image Placeholder 1"/>
+          <p:cNvSpPr>
+            <a:spLocks noGrp="1"/>
+          </p:cNvSpPr>
+          <p:nvPr>
+            <p:ph type="sldImg" idx="2"/>
+          </p:nvPr>
+        </p:nvSpPr>
+        <p:spPr/>
+      </p:sp>
+      <p:sp>
+        <p:nvSpPr>
+          <p:cNvPr id="3" name="Notes Placeholder 2"/>
+          <p:cNvSpPr>
+            <a:spLocks noGrp="1"/>
+          </p:cNvSpPr>
+          <p:nvPr>
+            <p:ph type="body" idx="3" sz="quarter"/>
+          </p:nvPr>
+        </p:nvSpPr>
+        <p:spPr/>
+        <p:txBody>
+          <a:bodyPr/>
+          <a:lstStyle/>
+          <a:p>
+            <a:r>
+              <a:rPr b="1" sz="1300">
+                <a:latin typeface="Geist Mono"/>
+              </a:rPr>
+              <a:t>The confusion matrix tells the real story</a:t>
+            </a:r>
+          </a:p>
+          <a:p>
+            <a:r>
+              <a:rPr b="0" sz="1100">
+                <a:latin typeface="Geist"/>
+              </a:rPr>
+              <a:t>A confusion matrix lays truth (rows) against the model's guess (columns). Correct answers sit on the diagonal; everything else is a mistake. Notice the one dark column: the model dumps almost every lesion, including cancers, into the common mole class. That is how it scores 0.68 while being useless for screening. Next we break accuracy apart class by class.</a:t>
+            </a:r>
+          </a:p>
+        </p:txBody>
+      </p:sp>
+      <p:sp>
+        <p:nvSpPr>
+          <p:cNvPr id="4" name="Slide Number Placeholder 3"/>
+          <p:cNvSpPr>
+            <a:spLocks noGrp="1"/>
+          </p:cNvSpPr>
+          <p:nvPr>
+            <p:ph type="sldNum" idx="5" sz="quarter"/>
+          </p:nvPr>
+        </p:nvSpPr>
+        <p:spPr/>
+      </p:sp>
+    </p:spTree>
+  </p:cSld>
+  <p:clrMapOvr>
+    <a:masterClrMapping/>
+  </p:clrMapOvr>
+</p:notes>
+</file>
+
+<file path=ppt/notesSlides/notesSlide11.xml><?xml version="1.0" encoding="utf-8"?>
+<p:notes xmlns:a="http://schemas.openxmlformats.org/drawingml/2006/main" xmlns:p="http://schemas.openxmlformats.org/presentationml/2006/main" xmlns:r="http://schemas.openxmlformats.org/officeDocument/2006/relationships">
+  <p:cSld>
+    <p:spTree>
+      <p:nvGrpSpPr>
+        <p:cNvPr id="1" name=""/>
+        <p:cNvGrpSpPr/>
+        <p:nvPr/>
+      </p:nvGrpSpPr>
+      <p:grpSpPr>
+        <a:xfrm>
+          <a:off x="0" y="0"/>
+          <a:ext cx="0" cy="0"/>
+          <a:chOff x="0" y="0"/>
+          <a:chExt cx="0" cy="0"/>
+        </a:xfrm>
+      </p:grpSpPr>
+      <p:sp>
+        <p:nvSpPr>
+          <p:cNvPr id="2" name="Slide Image Placeholder 1"/>
+          <p:cNvSpPr>
+            <a:spLocks noGrp="1"/>
+          </p:cNvSpPr>
+          <p:nvPr>
+            <p:ph type="sldImg" idx="2"/>
+          </p:nvPr>
+        </p:nvSpPr>
+        <p:spPr/>
+      </p:sp>
+      <p:sp>
+        <p:nvSpPr>
+          <p:cNvPr id="3" name="Notes Placeholder 2"/>
+          <p:cNvSpPr>
+            <a:spLocks noGrp="1"/>
+          </p:cNvSpPr>
+          <p:nvPr>
+            <p:ph type="body" idx="3" sz="quarter"/>
+          </p:nvPr>
+        </p:nvSpPr>
+        <p:spPr/>
+        <p:txBody>
+          <a:bodyPr/>
+          <a:lstStyle/>
+          <a:p>
+            <a:r>
+              <a:rPr b="1" sz="1300">
+                <a:latin typeface="Geist Mono"/>
+              </a:rPr>
+              <a:t>Screening lives or dies on the rare classes</a:t>
+            </a:r>
+          </a:p>
+          <a:p>
+            <a:r>
+              <a:rPr b="0" sz="1100">
+                <a:latin typeface="Geist"/>
+              </a:rPr>
+              <a:t>The dashed line is the 0.68 overall accuracy. Only the common mole class rises above it; every rare class, melanoma in pink included, sits near zero. An average can hide this completely. A screening tool has to work on the rare, dangerous classes -- and this one does not. Next, the single number that makes it undeniable.</a:t>
+            </a:r>
+          </a:p>
+        </p:txBody>
+      </p:sp>
+      <p:sp>
+        <p:nvSpPr>
+          <p:cNvPr id="4" name="Slide Number Placeholder 3"/>
+          <p:cNvSpPr>
+            <a:spLocks noGrp="1"/>
+          </p:cNvSpPr>
+          <p:nvPr>
+            <p:ph type="sldNum" idx="5" sz="quarter"/>
+          </p:nvPr>
+        </p:nvSpPr>
+        <p:spPr/>
+      </p:sp>
+    </p:spTree>
+  </p:cSld>
+  <p:clrMapOvr>
+    <a:masterClrMapping/>
+  </p:clrMapOvr>
+</p:notes>
+</file>
+
+<file path=ppt/notesSlides/notesSlide12.xml><?xml version="1.0" encoding="utf-8"?>
+<p:notes xmlns:a="http://schemas.openxmlformats.org/drawingml/2006/main" xmlns:p="http://schemas.openxmlformats.org/presentationml/2006/main" xmlns:r="http://schemas.openxmlformats.org/officeDocument/2006/relationships">
+  <p:cSld>
+    <p:spTree>
+      <p:nvGrpSpPr>
+        <p:cNvPr id="1" name=""/>
+        <p:cNvGrpSpPr/>
+        <p:nvPr/>
+      </p:nvGrpSpPr>
+      <p:grpSpPr>
+        <a:xfrm>
+          <a:off x="0" y="0"/>
+          <a:ext cx="0" cy="0"/>
+          <a:chOff x="0" y="0"/>
+          <a:chExt cx="0" cy="0"/>
+        </a:xfrm>
+      </p:grpSpPr>
+      <p:sp>
+        <p:nvSpPr>
+          <p:cNvPr id="2" name="Slide Image Placeholder 1"/>
+          <p:cNvSpPr>
+            <a:spLocks noGrp="1"/>
+          </p:cNvSpPr>
+          <p:nvPr>
+            <p:ph type="sldImg" idx="2"/>
+          </p:nvPr>
+        </p:nvSpPr>
+        <p:spPr/>
+      </p:sp>
+      <p:sp>
+        <p:nvSpPr>
+          <p:cNvPr id="3" name="Notes Placeholder 2"/>
+          <p:cNvSpPr>
+            <a:spLocks noGrp="1"/>
+          </p:cNvSpPr>
+          <p:nvPr>
+            <p:ph type="body" idx="3" sz="quarter"/>
+          </p:nvPr>
+        </p:nvSpPr>
+        <p:spPr/>
+        <p:txBody>
+          <a:bodyPr/>
+          <a:lstStyle/>
+          <a:p>
+            <a:r>
+              <a:rPr b="1" sz="1300">
+                <a:latin typeface="Geist Mono"/>
+              </a:rPr>
+              <a:t>The one number that matters: melanoma recall</a:t>
+            </a:r>
+          </a:p>
+          <a:p>
+            <a:r>
+              <a:rPr b="0" sz="1100">
+                <a:latin typeface="Geist"/>
+              </a:rPr>
+              <a:t>The emotional peak. The model looks respectable at 68% accuracy, yet it caught only 10 of 223 melanomas and missed 213 of them. Recall of 4.5% means it would wave almost every real cancer through as harmless. The sentence to remember: a healthy-looking accuracy number can hide a dangerous screening tool. Next we look those mistakes in the eye.</a:t>
+            </a:r>
+          </a:p>
+        </p:txBody>
+      </p:sp>
+      <p:sp>
+        <p:nvSpPr>
+          <p:cNvPr id="4" name="Slide Number Placeholder 3"/>
+          <p:cNvSpPr>
+            <a:spLocks noGrp="1"/>
+          </p:cNvSpPr>
+          <p:nvPr>
+            <p:ph type="sldNum" idx="5" sz="quarter"/>
+          </p:nvPr>
+        </p:nvSpPr>
+        <p:spPr/>
+      </p:sp>
+    </p:spTree>
+  </p:cSld>
+  <p:clrMapOvr>
+    <a:masterClrMapping/>
+  </p:clrMapOvr>
+</p:notes>
+</file>
+
+<file path=ppt/notesSlides/notesSlide13.xml><?xml version="1.0" encoding="utf-8"?>
+<p:notes xmlns:a="http://schemas.openxmlformats.org/drawingml/2006/main" xmlns:p="http://schemas.openxmlformats.org/presentationml/2006/main" xmlns:r="http://schemas.openxmlformats.org/officeDocument/2006/relationships">
+  <p:cSld>
+    <p:spTree>
+      <p:nvGrpSpPr>
+        <p:cNvPr id="1" name=""/>
+        <p:cNvGrpSpPr/>
+        <p:nvPr/>
+      </p:nvGrpSpPr>
+      <p:grpSpPr>
+        <a:xfrm>
+          <a:off x="0" y="0"/>
+          <a:ext cx="0" cy="0"/>
+          <a:chOff x="0" y="0"/>
+          <a:chExt cx="0" cy="0"/>
+        </a:xfrm>
+      </p:grpSpPr>
+      <p:sp>
+        <p:nvSpPr>
+          <p:cNvPr id="2" name="Slide Image Placeholder 1"/>
+          <p:cNvSpPr>
+            <a:spLocks noGrp="1"/>
+          </p:cNvSpPr>
+          <p:nvPr>
+            <p:ph type="sldImg" idx="2"/>
+          </p:nvPr>
+        </p:nvSpPr>
+        <p:spPr/>
+      </p:sp>
+      <p:sp>
+        <p:nvSpPr>
+          <p:cNvPr id="3" name="Notes Placeholder 2"/>
+          <p:cNvSpPr>
+            <a:spLocks noGrp="1"/>
+          </p:cNvSpPr>
+          <p:nvPr>
+            <p:ph type="body" idx="3" sz="quarter"/>
+          </p:nvPr>
+        </p:nvSpPr>
+        <p:spPr/>
+        <p:txBody>
+          <a:bodyPr/>
+          <a:lstStyle/>
+          <a:p>
+            <a:r>
+              <a:rPr b="1" sz="1300">
+                <a:latin typeface="Geist Mono"/>
+              </a:rPr>
+              <a:t>The cases it got wrong are the ones that matter</a:t>
+            </a:r>
+          </a:p>
+          <a:p>
+            <a:r>
+              <a:rPr b="0" sz="1100">
+                <a:latin typeface="Geist"/>
+              </a:rPr>
+              <a:t>These are real test lesions the model got wrong, with the truth and the guess printed above each. Count how many true melanomas it called melanocyti -- a harmless mole. Each is a false negative, the precise mistake screening exists to catch. Seeing the errors as images, not numbers, is what makes the risk real. Now let us be honest about what this toy can and cannot do.</a:t>
+            </a:r>
+          </a:p>
+        </p:txBody>
+      </p:sp>
+      <p:sp>
+        <p:nvSpPr>
+          <p:cNvPr id="4" name="Slide Number Placeholder 3"/>
+          <p:cNvSpPr>
+            <a:spLocks noGrp="1"/>
+          </p:cNvSpPr>
+          <p:nvPr>
+            <p:ph type="sldNum" idx="5" sz="quarter"/>
+          </p:nvPr>
+        </p:nvSpPr>
+        <p:spPr/>
+      </p:sp>
+    </p:spTree>
+  </p:cSld>
+  <p:clrMapOvr>
+    <a:masterClrMapping/>
+  </p:clrMapOvr>
+</p:notes>
+</file>
+
+<file path=ppt/notesSlides/notesSlide14.xml><?xml version="1.0" encoding="utf-8"?>
+<p:notes xmlns:a="http://schemas.openxmlformats.org/drawingml/2006/main" xmlns:p="http://schemas.openxmlformats.org/presentationml/2006/main" xmlns:r="http://schemas.openxmlformats.org/officeDocument/2006/relationships">
+  <p:cSld>
+    <p:spTree>
+      <p:nvGrpSpPr>
+        <p:cNvPr id="1" name=""/>
+        <p:cNvGrpSpPr/>
+        <p:nvPr/>
+      </p:nvGrpSpPr>
+      <p:grpSpPr>
+        <a:xfrm>
+          <a:off x="0" y="0"/>
+          <a:ext cx="0" cy="0"/>
+          <a:chOff x="0" y="0"/>
+          <a:chExt cx="0" cy="0"/>
+        </a:xfrm>
+      </p:grpSpPr>
+      <p:sp>
+        <p:nvSpPr>
+          <p:cNvPr id="2" name="Slide Image Placeholder 1"/>
+          <p:cNvSpPr>
+            <a:spLocks noGrp="1"/>
+          </p:cNvSpPr>
+          <p:nvPr>
+            <p:ph type="sldImg" idx="2"/>
+          </p:nvPr>
+        </p:nvSpPr>
+        <p:spPr/>
+      </p:sp>
+      <p:sp>
+        <p:nvSpPr>
+          <p:cNvPr id="3" name="Notes Placeholder 2"/>
+          <p:cNvSpPr>
+            <a:spLocks noGrp="1"/>
+          </p:cNvSpPr>
+          <p:nvPr>
+            <p:ph type="body" idx="3" sz="quarter"/>
+          </p:nvPr>
+        </p:nvSpPr>
+        <p:spPr/>
+        <p:txBody>
+          <a:bodyPr/>
+          <a:lstStyle/>
+          <a:p>
+            <a:r>
+              <a:rPr b="1" sz="1300">
+                <a:latin typeface="Geist Mono"/>
+              </a:rPr>
+              <a:t>Being honest</a:t>
+            </a:r>
+          </a:p>
+          <a:p>
+            <a:r>
+              <a:rPr b="0" sz="1100">
+                <a:latin typeface="Geist"/>
+              </a:rPr>
+              <a:t>Finally, the limits: why this toy model is not safe for real patients, what a real tool would need, and the mindset that actually transfers.</a:t>
+            </a:r>
+          </a:p>
+        </p:txBody>
+      </p:sp>
+      <p:sp>
+        <p:nvSpPr>
+          <p:cNvPr id="4" name="Slide Number Placeholder 3"/>
+          <p:cNvSpPr>
+            <a:spLocks noGrp="1"/>
+          </p:cNvSpPr>
+          <p:nvPr>
+            <p:ph type="sldNum" idx="5" sz="quarter"/>
+          </p:nvPr>
+        </p:nvSpPr>
+        <p:spPr/>
+      </p:sp>
+    </p:spTree>
+  </p:cSld>
+  <p:clrMapOvr>
+    <a:masterClrMapping/>
+  </p:clrMapOvr>
+</p:notes>
+</file>
+
+<file path=ppt/notesSlides/notesSlide15.xml><?xml version="1.0" encoding="utf-8"?>
+<p:notes xmlns:a="http://schemas.openxmlformats.org/drawingml/2006/main" xmlns:p="http://schemas.openxmlformats.org/presentationml/2006/main" xmlns:r="http://schemas.openxmlformats.org/officeDocument/2006/relationships">
+  <p:cSld>
+    <p:spTree>
+      <p:nvGrpSpPr>
+        <p:cNvPr id="1" name=""/>
+        <p:cNvGrpSpPr/>
+        <p:nvPr/>
+      </p:nvGrpSpPr>
+      <p:grpSpPr>
+        <a:xfrm>
+          <a:off x="0" y="0"/>
+          <a:ext cx="0" cy="0"/>
+          <a:chOff x="0" y="0"/>
+          <a:chExt cx="0" cy="0"/>
+        </a:xfrm>
+      </p:grpSpPr>
+      <p:sp>
+        <p:nvSpPr>
+          <p:cNvPr id="2" name="Slide Image Placeholder 1"/>
+          <p:cNvSpPr>
+            <a:spLocks noGrp="1"/>
+          </p:cNvSpPr>
+          <p:nvPr>
+            <p:ph type="sldImg" idx="2"/>
+          </p:nvPr>
+        </p:nvSpPr>
+        <p:spPr/>
+      </p:sp>
+      <p:sp>
+        <p:nvSpPr>
+          <p:cNvPr id="3" name="Notes Placeholder 2"/>
+          <p:cNvSpPr>
+            <a:spLocks noGrp="1"/>
+          </p:cNvSpPr>
+          <p:nvPr>
+            <p:ph type="body" idx="3" sz="quarter"/>
+          </p:nvPr>
+        </p:nvSpPr>
+        <p:spPr/>
+        <p:txBody>
+          <a:bodyPr/>
+          <a:lstStyle/>
+          <a:p>
+            <a:r>
+              <a:rPr b="1" sz="1300">
+                <a:latin typeface="Geist Mono"/>
+              </a:rPr>
+              <a:t>A toy model, and why that is exactly the point</a:t>
+            </a:r>
+          </a:p>
+          <a:p>
+            <a:r>
+              <a:rPr b="0" sz="1100">
+                <a:latin typeface="Geist"/>
+              </a:rPr>
+              <a:t>Be honest about the limits. Our input is tiny 64-pixel grayscale thumbnails, which discard the color and texture real dermatology depends on, so a 4.5% recall is expected, not surprising. A deployable tool would use full-resolution color, tune the threshold for sensitivity, and be validated across many sites. The real lesson is the mindset: never miss the dangerous case, and never trust a shiny accuracy number.</a:t>
+            </a:r>
+          </a:p>
+        </p:txBody>
+      </p:sp>
+      <p:sp>
+        <p:nvSpPr>
+          <p:cNvPr id="4" name="Slide Number Placeholder 3"/>
+          <p:cNvSpPr>
+            <a:spLocks noGrp="1"/>
+          </p:cNvSpPr>
+          <p:nvPr>
+            <p:ph type="sldNum" idx="5" sz="quarter"/>
+          </p:nvPr>
+        </p:nvSpPr>
+        <p:spPr/>
+      </p:sp>
+    </p:spTree>
+  </p:cSld>
+  <p:clrMapOvr>
+    <a:masterClrMapping/>
+  </p:clrMapOvr>
+</p:notes>
+</file>
+
+<file path=ppt/notesSlides/notesSlide16.xml><?xml version="1.0" encoding="utf-8"?>
+<p:notes xmlns:a="http://schemas.openxmlformats.org/drawingml/2006/main" xmlns:p="http://schemas.openxmlformats.org/presentationml/2006/main" xmlns:r="http://schemas.openxmlformats.org/officeDocument/2006/relationships">
+  <p:cSld>
+    <p:spTree>
+      <p:nvGrpSpPr>
+        <p:cNvPr id="1" name=""/>
+        <p:cNvGrpSpPr/>
+        <p:nvPr/>
+      </p:nvGrpSpPr>
+      <p:grpSpPr>
+        <a:xfrm>
+          <a:off x="0" y="0"/>
+          <a:ext cx="0" cy="0"/>
+          <a:chOff x="0" y="0"/>
+          <a:chExt cx="0" cy="0"/>
+        </a:xfrm>
+      </p:grpSpPr>
+      <p:sp>
+        <p:nvSpPr>
+          <p:cNvPr id="2" name="Slide Image Placeholder 1"/>
+          <p:cNvSpPr>
+            <a:spLocks noGrp="1"/>
+          </p:cNvSpPr>
+          <p:nvPr>
+            <p:ph type="sldImg" idx="2"/>
+          </p:nvPr>
+        </p:nvSpPr>
+        <p:spPr/>
+      </p:sp>
+      <p:sp>
+        <p:nvSpPr>
+          <p:cNvPr id="3" name="Notes Placeholder 2"/>
+          <p:cNvSpPr>
+            <a:spLocks noGrp="1"/>
+          </p:cNvSpPr>
+          <p:nvPr>
+            <p:ph type="body" idx="3" sz="quarter"/>
+          </p:nvPr>
+        </p:nvSpPr>
+        <p:spPr/>
+        <p:txBody>
+          <a:bodyPr/>
+          <a:lstStyle/>
+          <a:p>
+            <a:r>
+              <a:rPr b="1" sz="1300">
+                <a:latin typeface="Geist Mono"/>
+              </a:rPr>
+              <a:t>References, and thank you</a:t>
+            </a:r>
+          </a:p>
+          <a:p>
+            <a:r>
+              <a:rPr b="0" sz="1100">
+                <a:latin typeface="Geist"/>
+              </a:rPr>
+              <a:t>These are the seven references behind the project, from the landmark dermatologist-level results that launched the field to the plain-language primer on why sensitivity matters. The closing thought: the score was never the point -- honest evaluation was. Thank the audience and invite questions.</a:t>
+            </a:r>
+          </a:p>
+        </p:txBody>
+      </p:sp>
+      <p:sp>
+        <p:nvSpPr>
+          <p:cNvPr id="4" name="Slide Number Placeholder 3"/>
+          <p:cNvSpPr>
+            <a:spLocks noGrp="1"/>
+          </p:cNvSpPr>
+          <p:nvPr>
+            <p:ph type="sldNum" idx="5" sz="quarter"/>
+          </p:nvPr>
+        </p:nvSpPr>
+        <p:spPr/>
+      </p:sp>
+    </p:spTree>
+  </p:cSld>
+  <p:clrMapOvr>
+    <a:masterClrMapping/>
+  </p:clrMapOvr>
+</p:notes>
+</file>
+
+<file path=ppt/notesSlides/notesSlide2.xml><?xml version="1.0" encoding="utf-8"?>
+<p:notes xmlns:a="http://schemas.openxmlformats.org/drawingml/2006/main" xmlns:p="http://schemas.openxmlformats.org/presentationml/2006/main" xmlns:r="http://schemas.openxmlformats.org/officeDocument/2006/relationships">
+  <p:cSld>
+    <p:spTree>
+      <p:nvGrpSpPr>
+        <p:cNvPr id="1" name=""/>
+        <p:cNvGrpSpPr/>
+        <p:nvPr/>
+      </p:nvGrpSpPr>
+      <p:grpSpPr>
+        <a:xfrm>
+          <a:off x="0" y="0"/>
+          <a:ext cx="0" cy="0"/>
+          <a:chOff x="0" y="0"/>
+          <a:chExt cx="0" cy="0"/>
+        </a:xfrm>
+      </p:grpSpPr>
+      <p:sp>
+        <p:nvSpPr>
+          <p:cNvPr id="2" name="Slide Image Placeholder 1"/>
+          <p:cNvSpPr>
+            <a:spLocks noGrp="1"/>
+          </p:cNvSpPr>
+          <p:nvPr>
+            <p:ph type="sldImg" idx="2"/>
+          </p:nvPr>
+        </p:nvSpPr>
+        <p:spPr/>
+      </p:sp>
+      <p:sp>
+        <p:nvSpPr>
+          <p:cNvPr id="3" name="Notes Placeholder 2"/>
+          <p:cNvSpPr>
+            <a:spLocks noGrp="1"/>
+          </p:cNvSpPr>
+          <p:nvPr>
+            <p:ph type="body" idx="3" sz="quarter"/>
+          </p:nvPr>
+        </p:nvSpPr>
+        <p:spPr/>
+        <p:txBody>
+          <a:bodyPr/>
+          <a:lstStyle/>
+          <a:p>
+            <a:r>
+              <a:rPr b="1" sz="1300">
+                <a:latin typeface="Geist Mono"/>
+              </a:rPr>
+              <a:t>Two mistakes, and only one of them can be fatal</a:t>
+            </a:r>
+          </a:p>
+          <a:p>
+            <a:r>
+              <a:rPr b="0" sz="1100">
+                <a:latin typeface="Geist"/>
+              </a:rPr>
+              <a:t>The core idea of the whole talk: the two kinds of mistake are not equal. A false alarm just costs a follow-up visit, but a missed melanoma can be fatal. That asymmetry is why we will judge the model on catching cancers, not on overall accuracy. Next we make the trade-off concrete with a single dial.</a:t>
+            </a:r>
+          </a:p>
+        </p:txBody>
+      </p:sp>
+      <p:sp>
+        <p:nvSpPr>
+          <p:cNvPr id="4" name="Slide Number Placeholder 3"/>
+          <p:cNvSpPr>
+            <a:spLocks noGrp="1"/>
+          </p:cNvSpPr>
+          <p:nvPr>
+            <p:ph type="sldNum" idx="5" sz="quarter"/>
+          </p:nvPr>
+        </p:nvSpPr>
+        <p:spPr/>
+      </p:sp>
+    </p:spTree>
+  </p:cSld>
+  <p:clrMapOvr>
+    <a:masterClrMapping/>
+  </p:clrMapOvr>
+</p:notes>
+</file>
+
+<file path=ppt/notesSlides/notesSlide3.xml><?xml version="1.0" encoding="utf-8"?>
+<p:notes xmlns:a="http://schemas.openxmlformats.org/drawingml/2006/main" xmlns:p="http://schemas.openxmlformats.org/presentationml/2006/main" xmlns:r="http://schemas.openxmlformats.org/officeDocument/2006/relationships">
+  <p:cSld>
+    <p:spTree>
+      <p:nvGrpSpPr>
+        <p:cNvPr id="1" name=""/>
+        <p:cNvGrpSpPr/>
+        <p:nvPr/>
+      </p:nvGrpSpPr>
+      <p:grpSpPr>
+        <a:xfrm>
+          <a:off x="0" y="0"/>
+          <a:ext cx="0" cy="0"/>
+          <a:chOff x="0" y="0"/>
+          <a:chExt cx="0" cy="0"/>
+        </a:xfrm>
+      </p:grpSpPr>
+      <p:sp>
+        <p:nvSpPr>
+          <p:cNvPr id="2" name="Slide Image Placeholder 1"/>
+          <p:cNvSpPr>
+            <a:spLocks noGrp="1"/>
+          </p:cNvSpPr>
+          <p:nvPr>
+            <p:ph type="sldImg" idx="2"/>
+          </p:nvPr>
+        </p:nvSpPr>
+        <p:spPr/>
+      </p:sp>
+      <p:sp>
+        <p:nvSpPr>
+          <p:cNvPr id="3" name="Notes Placeholder 2"/>
+          <p:cNvSpPr>
+            <a:spLocks noGrp="1"/>
+          </p:cNvSpPr>
+          <p:nvPr>
+            <p:ph type="body" idx="3" sz="quarter"/>
+          </p:nvPr>
+        </p:nvSpPr>
+        <p:spPr/>
+        <p:txBody>
+          <a:bodyPr/>
+          <a:lstStyle/>
+          <a:p>
+            <a:r>
+              <a:rPr b="1" sz="1300">
+                <a:latin typeface="Geist Mono"/>
+              </a:rPr>
+              <a:t>Screening tunes one dial: sensitivity versus specificity</a:t>
+            </a:r>
+          </a:p>
+          <a:p>
+            <a:r>
+              <a:rPr b="0" sz="1100">
+                <a:latin typeface="Geist"/>
+              </a:rPr>
+              <a:t>The two bell curves are the model's cancer scores for healthy spots (left) and true melanomas (right). The dashed line is the threshold that turns a score into a yes-or-no call. Sliding it left catches more melanomas at the cost of more false alarms. Screening tools deliberately live on the left. Next: how we teach the model to see with so few images.</a:t>
+            </a:r>
+          </a:p>
+        </p:txBody>
+      </p:sp>
+      <p:sp>
+        <p:nvSpPr>
+          <p:cNvPr id="4" name="Slide Number Placeholder 3"/>
+          <p:cNvSpPr>
+            <a:spLocks noGrp="1"/>
+          </p:cNvSpPr>
+          <p:nvPr>
+            <p:ph type="sldNum" idx="5" sz="quarter"/>
+          </p:nvPr>
+        </p:nvSpPr>
+        <p:spPr/>
+      </p:sp>
+    </p:spTree>
+  </p:cSld>
+  <p:clrMapOvr>
+    <a:masterClrMapping/>
+  </p:clrMapOvr>
+</p:notes>
+</file>
+
+<file path=ppt/notesSlides/notesSlide4.xml><?xml version="1.0" encoding="utf-8"?>
+<p:notes xmlns:a="http://schemas.openxmlformats.org/drawingml/2006/main" xmlns:p="http://schemas.openxmlformats.org/presentationml/2006/main" xmlns:r="http://schemas.openxmlformats.org/officeDocument/2006/relationships">
+  <p:cSld>
+    <p:spTree>
+      <p:nvGrpSpPr>
+        <p:cNvPr id="1" name=""/>
+        <p:cNvGrpSpPr/>
+        <p:nvPr/>
+      </p:nvGrpSpPr>
+      <p:grpSpPr>
+        <a:xfrm>
+          <a:off x="0" y="0"/>
+          <a:ext cx="0" cy="0"/>
+          <a:chOff x="0" y="0"/>
+          <a:chExt cx="0" cy="0"/>
+        </a:xfrm>
+      </p:grpSpPr>
+      <p:sp>
+        <p:nvSpPr>
+          <p:cNvPr id="2" name="Slide Image Placeholder 1"/>
+          <p:cNvSpPr>
+            <a:spLocks noGrp="1"/>
+          </p:cNvSpPr>
+          <p:nvPr>
+            <p:ph type="sldImg" idx="2"/>
+          </p:nvPr>
+        </p:nvSpPr>
+        <p:spPr/>
+      </p:sp>
+      <p:sp>
+        <p:nvSpPr>
+          <p:cNvPr id="3" name="Notes Placeholder 2"/>
+          <p:cNvSpPr>
+            <a:spLocks noGrp="1"/>
+          </p:cNvSpPr>
+          <p:nvPr>
+            <p:ph type="body" idx="3" sz="quarter"/>
+          </p:nvPr>
+        </p:nvSpPr>
+        <p:spPr/>
+        <p:txBody>
+          <a:bodyPr/>
+          <a:lstStyle/>
+          <a:p>
+            <a:r>
+              <a:rPr b="1" sz="1300">
+                <a:latin typeface="Geist Mono"/>
+              </a:rPr>
+              <a:t>We borrow a brain instead of starting blank</a:t>
+            </a:r>
+          </a:p>
+          <a:p>
+            <a:r>
+              <a:rPr b="0" sz="1100">
+                <a:latin typeface="Geist"/>
+              </a:rPr>
+              <a:t>Transfer learning is the trick that makes small medical datasets workable. A network pre-trained on ordinary photos already understands edges, colors, and textures, so we only teach it the last step -- melanoma versus not. Reusing that borrowed vision is why thousands of images are enough. Now we turn to the actual dataset and task.</a:t>
+            </a:r>
+          </a:p>
+        </p:txBody>
+      </p:sp>
+      <p:sp>
+        <p:nvSpPr>
+          <p:cNvPr id="4" name="Slide Number Placeholder 3"/>
+          <p:cNvSpPr>
+            <a:spLocks noGrp="1"/>
+          </p:cNvSpPr>
+          <p:nvPr>
+            <p:ph type="sldNum" idx="5" sz="quarter"/>
+          </p:nvPr>
+        </p:nvSpPr>
+        <p:spPr/>
+      </p:sp>
+    </p:spTree>
+  </p:cSld>
+  <p:clrMapOvr>
+    <a:masterClrMapping/>
+  </p:clrMapOvr>
+</p:notes>
+</file>
+
+<file path=ppt/notesSlides/notesSlide5.xml><?xml version="1.0" encoding="utf-8"?>
+<p:notes xmlns:a="http://schemas.openxmlformats.org/drawingml/2006/main" xmlns:p="http://schemas.openxmlformats.org/presentationml/2006/main" xmlns:r="http://schemas.openxmlformats.org/officeDocument/2006/relationships">
+  <p:cSld>
+    <p:spTree>
+      <p:nvGrpSpPr>
+        <p:cNvPr id="1" name=""/>
+        <p:cNvGrpSpPr/>
+        <p:nvPr/>
+      </p:nvGrpSpPr>
+      <p:grpSpPr>
+        <a:xfrm>
+          <a:off x="0" y="0"/>
+          <a:ext cx="0" cy="0"/>
+          <a:chOff x="0" y="0"/>
+          <a:chExt cx="0" cy="0"/>
+        </a:xfrm>
+      </p:grpSpPr>
+      <p:sp>
+        <p:nvSpPr>
+          <p:cNvPr id="2" name="Slide Image Placeholder 1"/>
+          <p:cNvSpPr>
+            <a:spLocks noGrp="1"/>
+          </p:cNvSpPr>
+          <p:nvPr>
+            <p:ph type="sldImg" idx="2"/>
+          </p:nvPr>
+        </p:nvSpPr>
+        <p:spPr/>
+      </p:sp>
+      <p:sp>
+        <p:nvSpPr>
+          <p:cNvPr id="3" name="Notes Placeholder 2"/>
+          <p:cNvSpPr>
+            <a:spLocks noGrp="1"/>
+          </p:cNvSpPr>
+          <p:nvPr>
+            <p:ph type="body" idx="3" sz="quarter"/>
+          </p:nvPr>
+        </p:nvSpPr>
+        <p:spPr/>
+        <p:txBody>
+          <a:bodyPr/>
+          <a:lstStyle/>
+          <a:p>
+            <a:r>
+              <a:rPr b="1" sz="1300">
+                <a:latin typeface="Geist Mono"/>
+              </a:rPr>
+              <a:t>Methods</a:t>
+            </a:r>
+          </a:p>
+          <a:p>
+            <a:r>
+              <a:rPr b="0" sz="1100">
+                <a:latin typeface="Geist"/>
+              </a:rPr>
+              <a:t>Now we describe the data and the experiment -- the seven-class DermaMNIST task and, crucially, the honest way we chose to grade the model.</a:t>
+            </a:r>
+          </a:p>
+        </p:txBody>
+      </p:sp>
+      <p:sp>
+        <p:nvSpPr>
+          <p:cNvPr id="4" name="Slide Number Placeholder 3"/>
+          <p:cNvSpPr>
+            <a:spLocks noGrp="1"/>
+          </p:cNvSpPr>
+          <p:nvPr>
+            <p:ph type="sldNum" idx="5" sz="quarter"/>
+          </p:nvPr>
+        </p:nvSpPr>
+        <p:spPr/>
+      </p:sp>
+    </p:spTree>
+  </p:cSld>
+  <p:clrMapOvr>
+    <a:masterClrMapping/>
+  </p:clrMapOvr>
+</p:notes>
+</file>
+
+<file path=ppt/notesSlides/notesSlide6.xml><?xml version="1.0" encoding="utf-8"?>
+<p:notes xmlns:a="http://schemas.openxmlformats.org/drawingml/2006/main" xmlns:p="http://schemas.openxmlformats.org/presentationml/2006/main" xmlns:r="http://schemas.openxmlformats.org/officeDocument/2006/relationships">
+  <p:cSld>
+    <p:spTree>
+      <p:nvGrpSpPr>
+        <p:cNvPr id="1" name=""/>
+        <p:cNvGrpSpPr/>
+        <p:nvPr/>
+      </p:nvGrpSpPr>
+      <p:grpSpPr>
+        <a:xfrm>
+          <a:off x="0" y="0"/>
+          <a:ext cx="0" cy="0"/>
+          <a:chOff x="0" y="0"/>
+          <a:chExt cx="0" cy="0"/>
+        </a:xfrm>
+      </p:grpSpPr>
+      <p:sp>
+        <p:nvSpPr>
+          <p:cNvPr id="2" name="Slide Image Placeholder 1"/>
+          <p:cNvSpPr>
+            <a:spLocks noGrp="1"/>
+          </p:cNvSpPr>
+          <p:nvPr>
+            <p:ph type="sldImg" idx="2"/>
+          </p:nvPr>
+        </p:nvSpPr>
+        <p:spPr/>
+      </p:sp>
+      <p:sp>
+        <p:nvSpPr>
+          <p:cNvPr id="3" name="Notes Placeholder 2"/>
+          <p:cNvSpPr>
+            <a:spLocks noGrp="1"/>
+          </p:cNvSpPr>
+          <p:nvPr>
+            <p:ph type="body" idx="3" sz="quarter"/>
+          </p:nvPr>
+        </p:nvSpPr>
+        <p:spPr/>
+        <p:txBody>
+          <a:bodyPr/>
+          <a:lstStyle/>
+          <a:p>
+            <a:r>
+              <a:rPr b="1" sz="1300">
+                <a:latin typeface="Geist Mono"/>
+              </a:rPr>
+              <a:t>The task: seven kinds of skin spot, one that we cannot miss</a:t>
+            </a:r>
+          </a:p>
+          <a:p>
+            <a:r>
+              <a:rPr b="0" sz="1100">
+                <a:latin typeface="Geist"/>
+              </a:rPr>
+              <a:t>DermaMNIST is a clean, student-friendly version of the real HAM10000 dermatoscopy images, with seven lesion types. The key feature is severe class imbalance: harmless moles dominate. That imbalance is a trap, because a model can score high accuracy just by guessing mole every time. Next: how we trained, and more importantly how we graded honestly.</a:t>
+            </a:r>
+          </a:p>
+        </p:txBody>
+      </p:sp>
+      <p:sp>
+        <p:nvSpPr>
+          <p:cNvPr id="4" name="Slide Number Placeholder 3"/>
+          <p:cNvSpPr>
+            <a:spLocks noGrp="1"/>
+          </p:cNvSpPr>
+          <p:nvPr>
+            <p:ph type="sldNum" idx="5" sz="quarter"/>
+          </p:nvPr>
+        </p:nvSpPr>
+        <p:spPr/>
+      </p:sp>
+    </p:spTree>
+  </p:cSld>
+  <p:clrMapOvr>
+    <a:masterClrMapping/>
+  </p:clrMapOvr>
+</p:notes>
+</file>
+
+<file path=ppt/notesSlides/notesSlide7.xml><?xml version="1.0" encoding="utf-8"?>
+<p:notes xmlns:a="http://schemas.openxmlformats.org/drawingml/2006/main" xmlns:p="http://schemas.openxmlformats.org/presentationml/2006/main" xmlns:r="http://schemas.openxmlformats.org/officeDocument/2006/relationships">
+  <p:cSld>
+    <p:spTree>
+      <p:nvGrpSpPr>
+        <p:cNvPr id="1" name=""/>
+        <p:cNvGrpSpPr/>
+        <p:nvPr/>
+      </p:nvGrpSpPr>
+      <p:grpSpPr>
+        <a:xfrm>
+          <a:off x="0" y="0"/>
+          <a:ext cx="0" cy="0"/>
+          <a:chOff x="0" y="0"/>
+          <a:chExt cx="0" cy="0"/>
+        </a:xfrm>
+      </p:grpSpPr>
+      <p:sp>
+        <p:nvSpPr>
+          <p:cNvPr id="2" name="Slide Image Placeholder 1"/>
+          <p:cNvSpPr>
+            <a:spLocks noGrp="1"/>
+          </p:cNvSpPr>
+          <p:nvPr>
+            <p:ph type="sldImg" idx="2"/>
+          </p:nvPr>
+        </p:nvSpPr>
+        <p:spPr/>
+      </p:sp>
+      <p:sp>
+        <p:nvSpPr>
+          <p:cNvPr id="3" name="Notes Placeholder 2"/>
+          <p:cNvSpPr>
+            <a:spLocks noGrp="1"/>
+          </p:cNvSpPr>
+          <p:nvPr>
+            <p:ph type="body" idx="3" sz="quarter"/>
+          </p:nvPr>
+        </p:nvSpPr>
+        <p:spPr/>
+        <p:txBody>
+          <a:bodyPr/>
+          <a:lstStyle/>
+          <a:p>
+            <a:r>
+              <a:rPr b="1" sz="1300">
+                <a:latin typeface="Geist Mono"/>
+              </a:rPr>
+              <a:t>How we built it, and how we graded it honestly</a:t>
+            </a:r>
+          </a:p>
+          <a:p>
+            <a:r>
+              <a:rPr b="0" sz="1100">
+                <a:latin typeface="Geist"/>
+              </a:rPr>
+              <a:t>We ran three versions to see whether a better starting point or a fancier trick mattered more. Crucially we did not grade on accuracy alone. We tracked melanoma recall -- the fraction of real melanomas actually caught -- because on imbalanced data that is the number that reflects safety. The results section shows what we found.</a:t>
+            </a:r>
+          </a:p>
+        </p:txBody>
+      </p:sp>
+      <p:sp>
+        <p:nvSpPr>
+          <p:cNvPr id="4" name="Slide Number Placeholder 3"/>
+          <p:cNvSpPr>
+            <a:spLocks noGrp="1"/>
+          </p:cNvSpPr>
+          <p:nvPr>
+            <p:ph type="sldNum" idx="5" sz="quarter"/>
+          </p:nvPr>
+        </p:nvSpPr>
+        <p:spPr/>
+      </p:sp>
+    </p:spTree>
+  </p:cSld>
+  <p:clrMapOvr>
+    <a:masterClrMapping/>
+  </p:clrMapOvr>
+</p:notes>
+</file>
+
+<file path=ppt/notesSlides/notesSlide8.xml><?xml version="1.0" encoding="utf-8"?>
+<p:notes xmlns:a="http://schemas.openxmlformats.org/drawingml/2006/main" xmlns:p="http://schemas.openxmlformats.org/presentationml/2006/main" xmlns:r="http://schemas.openxmlformats.org/officeDocument/2006/relationships">
+  <p:cSld>
+    <p:spTree>
+      <p:nvGrpSpPr>
+        <p:cNvPr id="1" name=""/>
+        <p:cNvGrpSpPr/>
+        <p:nvPr/>
+      </p:nvGrpSpPr>
+      <p:grpSpPr>
+        <a:xfrm>
+          <a:off x="0" y="0"/>
+          <a:ext cx="0" cy="0"/>
+          <a:chOff x="0" y="0"/>
+          <a:chExt cx="0" cy="0"/>
+        </a:xfrm>
+      </p:grpSpPr>
+      <p:sp>
+        <p:nvSpPr>
+          <p:cNvPr id="2" name="Slide Image Placeholder 1"/>
+          <p:cNvSpPr>
+            <a:spLocks noGrp="1"/>
+          </p:cNvSpPr>
+          <p:nvPr>
+            <p:ph type="sldImg" idx="2"/>
+          </p:nvPr>
+        </p:nvSpPr>
+        <p:spPr/>
+      </p:sp>
+      <p:sp>
+        <p:nvSpPr>
+          <p:cNvPr id="3" name="Notes Placeholder 2"/>
+          <p:cNvSpPr>
+            <a:spLocks noGrp="1"/>
+          </p:cNvSpPr>
+          <p:nvPr>
+            <p:ph type="body" idx="3" sz="quarter"/>
+          </p:nvPr>
+        </p:nvSpPr>
+        <p:spPr/>
+        <p:txBody>
+          <a:bodyPr/>
+          <a:lstStyle/>
+          <a:p>
+            <a:r>
+              <a:rPr b="1" sz="1300">
+                <a:latin typeface="Geist Mono"/>
+              </a:rPr>
+              <a:t>Results</a:t>
+            </a:r>
+          </a:p>
+          <a:p>
+            <a:r>
+              <a:rPr b="0" sz="1100">
+                <a:latin typeface="Geist"/>
+              </a:rPr>
+              <a:t>Here are the real numbers. Watch how a respectable-looking accuracy falls apart the moment we look at the rare, dangerous classes.</a:t>
+            </a:r>
+          </a:p>
+        </p:txBody>
+      </p:sp>
+      <p:sp>
+        <p:nvSpPr>
+          <p:cNvPr id="4" name="Slide Number Placeholder 3"/>
+          <p:cNvSpPr>
+            <a:spLocks noGrp="1"/>
+          </p:cNvSpPr>
+          <p:nvPr>
+            <p:ph type="sldNum" idx="5" sz="quarter"/>
+          </p:nvPr>
+        </p:nvSpPr>
+        <p:spPr/>
+      </p:sp>
+    </p:spTree>
+  </p:cSld>
+  <p:clrMapOvr>
+    <a:masterClrMapping/>
+  </p:clrMapOvr>
+</p:notes>
+</file>
+
+<file path=ppt/notesSlides/notesSlide9.xml><?xml version="1.0" encoding="utf-8"?>
+<p:notes xmlns:a="http://schemas.openxmlformats.org/drawingml/2006/main" xmlns:p="http://schemas.openxmlformats.org/presentationml/2006/main" xmlns:r="http://schemas.openxmlformats.org/officeDocument/2006/relationships">
+  <p:cSld>
+    <p:spTree>
+      <p:nvGrpSpPr>
+        <p:cNvPr id="1" name=""/>
+        <p:cNvGrpSpPr/>
+        <p:nvPr/>
+      </p:nvGrpSpPr>
+      <p:grpSpPr>
+        <a:xfrm>
+          <a:off x="0" y="0"/>
+          <a:ext cx="0" cy="0"/>
+          <a:chOff x="0" y="0"/>
+          <a:chExt cx="0" cy="0"/>
+        </a:xfrm>
+      </p:grpSpPr>
+      <p:sp>
+        <p:nvSpPr>
+          <p:cNvPr id="2" name="Slide Image Placeholder 1"/>
+          <p:cNvSpPr>
+            <a:spLocks noGrp="1"/>
+          </p:cNvSpPr>
+          <p:nvPr>
+            <p:ph type="sldImg" idx="2"/>
+          </p:nvPr>
+        </p:nvSpPr>
+        <p:spPr/>
+      </p:sp>
+      <p:sp>
+        <p:nvSpPr>
+          <p:cNvPr id="3" name="Notes Placeholder 2"/>
+          <p:cNvSpPr>
+            <a:spLocks noGrp="1"/>
+          </p:cNvSpPr>
+          <p:nvPr>
+            <p:ph type="body" idx="3" sz="quarter"/>
+          </p:nvPr>
+        </p:nvSpPr>
+        <p:spPr/>
+        <p:txBody>
+          <a:bodyPr/>
+          <a:lstStyle/>
+          <a:p>
+            <a:r>
+              <a:rPr b="1" sz="1300">
+                <a:latin typeface="Geist Mono"/>
+              </a:rPr>
+              <a:t>A better starting point beat a fancier model</a:t>
+            </a:r>
+          </a:p>
+          <a:p>
+            <a:r>
+              <a:rPr b="0" sz="1100">
+                <a:latin typeface="Geist"/>
+              </a:rPr>
+              <a:t>All three bars sit at about 0.68 accuracy -- from-scratch, pretrained, and pretrained-plus-augmentation are basically tied. The lesson is humbling: when the data is this small and skewed, the data sets the ceiling, not the cleverness of the model. But this accuracy number is about to mislead us, which the next slide reveals.</a:t>
+            </a:r>
+          </a:p>
+        </p:txBody>
+      </p:sp>
+      <p:sp>
+        <p:nvSpPr>
+          <p:cNvPr id="4" name="Slide Number Placeholder 3"/>
+          <p:cNvSpPr>
+            <a:spLocks noGrp="1"/>
+          </p:cNvSpPr>
+          <p:nvPr>
+            <p:ph type="sldNum" idx="5" sz="quarter"/>
+          </p:nvPr>
+        </p:nvSpPr>
+        <p:spPr/>
+      </p:sp>
+    </p:spTree>
+  </p:cSld>
+  <p:clrMapOvr>
+    <a:masterClrMapping/>
+  </p:clrMapOvr>
+</p:notes>
 </file>
 
 <file path=ppt/slideLayouts/slideLayout1.xml><?xml version="1.0" encoding="utf-8"?>
@@ -3767,16 +5413,84 @@
           </a:p>
         </p:txBody>
       </p:sp>
-      <p:sp>
-        <p:nvSpPr>
-          <p:cNvPr id="7" name="TextBox 6"/>
+      <p:pic>
+        <p:nvPicPr>
+          <p:cNvPr id="7" name="Picture 6" descr="data_beats_model.png"/>
+          <p:cNvPicPr>
+            <a:picLocks noChangeAspect="1"/>
+          </p:cNvPicPr>
+          <p:nvPr/>
+        </p:nvPicPr>
+        <p:blipFill>
+          <a:blip r:embed="rId2"/>
+          <a:stretch>
+            <a:fillRect/>
+          </a:stretch>
+        </p:blipFill>
+        <p:spPr>
+          <a:xfrm>
+            <a:off x="457200" y="1406972"/>
+            <a:ext cx="6298387" cy="4364095"/>
+          </a:xfrm>
+          <a:prstGeom prst="rect">
+            <a:avLst/>
+          </a:prstGeom>
+        </p:spPr>
+      </p:pic>
+      <p:sp>
+        <p:nvSpPr>
+          <p:cNvPr id="8" name="Rectangle 7"/>
+          <p:cNvSpPr/>
+          <p:nvPr/>
+        </p:nvSpPr>
+        <p:spPr>
+          <a:xfrm>
+            <a:off x="7167067" y="1216152"/>
+            <a:ext cx="73152" cy="4553712"/>
+          </a:xfrm>
+          <a:prstGeom prst="rect">
+            <a:avLst/>
+          </a:prstGeom>
+          <a:solidFill>
+            <a:srgbClr val="F0C840"/>
+          </a:solidFill>
+          <a:ln>
+            <a:noFill/>
+          </a:ln>
+          <a:effectLst/>
+        </p:spPr>
+        <p:style>
+          <a:lnRef idx="1">
+            <a:schemeClr val="accent1"/>
+          </a:lnRef>
+          <a:fillRef idx="3">
+            <a:schemeClr val="accent1"/>
+          </a:fillRef>
+          <a:effectRef idx="2">
+            <a:schemeClr val="accent1"/>
+          </a:effectRef>
+          <a:fontRef idx="minor">
+            <a:schemeClr val="lt1"/>
+          </a:fontRef>
+        </p:style>
+        <p:txBody>
+          <a:bodyPr rtlCol="0" anchor="ctr"/>
+          <a:lstStyle/>
+          <a:p>
+            <a:pPr algn="ctr"/>
+          </a:p>
+        </p:txBody>
+      </p:sp>
+      <p:sp>
+        <p:nvSpPr>
+          <p:cNvPr id="9" name="TextBox 8"/>
           <p:cNvSpPr txBox="1"/>
           <p:nvPr/>
         </p:nvSpPr>
         <p:spPr>
           <a:xfrm>
-            <a:off x="548640" y="1234440"/>
-            <a:ext cx="11064240" cy="896112"/>
+            <a:off x="7441387" y="1097280"/>
+            <a:ext cx="4226356" cy="4800599"/>
           </a:xfrm>
           <a:prstGeom prst="rect">
             <a:avLst/>
@@ -3784,14 +5498,14 @@
           <a:noFill/>
         </p:spPr>
         <p:txBody>
-          <a:bodyPr wrap="square" anchor="t" lIns="0" rIns="0" tIns="0" bIns="0">
+          <a:bodyPr wrap="square" anchor="ctr" lIns="0" rIns="0" tIns="0" bIns="0">
             <a:spAutoFit/>
           </a:bodyPr>
           <a:lstStyle/>
           <a:p>
             <a:pPr algn="l"/>
             <a:r>
-              <a:rPr sz="1400" b="0" i="0">
+              <a:rPr sz="1700" b="0" i="0">
                 <a:solidFill>
                   <a:srgbClr val="14141C"/>
                 </a:solidFill>
@@ -4022,16 +5736,84 @@
           </a:p>
         </p:txBody>
       </p:sp>
-      <p:sp>
-        <p:nvSpPr>
-          <p:cNvPr id="7" name="TextBox 6"/>
+      <p:pic>
+        <p:nvPicPr>
+          <p:cNvPr id="7" name="Picture 6" descr="confusion.png"/>
+          <p:cNvPicPr>
+            <a:picLocks noChangeAspect="1"/>
+          </p:cNvPicPr>
+          <p:nvPr/>
+        </p:nvPicPr>
+        <p:blipFill>
+          <a:blip r:embed="rId2"/>
+          <a:stretch>
+            <a:fillRect/>
+          </a:stretch>
+        </p:blipFill>
+        <p:spPr>
+          <a:xfrm>
+            <a:off x="830748" y="1097280"/>
+            <a:ext cx="5101406" cy="4983479"/>
+          </a:xfrm>
+          <a:prstGeom prst="rect">
+            <a:avLst/>
+          </a:prstGeom>
+        </p:spPr>
+      </p:pic>
+      <p:sp>
+        <p:nvSpPr>
+          <p:cNvPr id="8" name="Rectangle 7"/>
+          <p:cNvSpPr/>
+          <p:nvPr/>
+        </p:nvSpPr>
+        <p:spPr>
+          <a:xfrm>
+            <a:off x="6717182" y="1216152"/>
+            <a:ext cx="73152" cy="4553712"/>
+          </a:xfrm>
+          <a:prstGeom prst="rect">
+            <a:avLst/>
+          </a:prstGeom>
+          <a:solidFill>
+            <a:srgbClr val="F0C840"/>
+          </a:solidFill>
+          <a:ln>
+            <a:noFill/>
+          </a:ln>
+          <a:effectLst/>
+        </p:spPr>
+        <p:style>
+          <a:lnRef idx="1">
+            <a:schemeClr val="accent1"/>
+          </a:lnRef>
+          <a:fillRef idx="3">
+            <a:schemeClr val="accent1"/>
+          </a:fillRef>
+          <a:effectRef idx="2">
+            <a:schemeClr val="accent1"/>
+          </a:effectRef>
+          <a:fontRef idx="minor">
+            <a:schemeClr val="lt1"/>
+          </a:fontRef>
+        </p:style>
+        <p:txBody>
+          <a:bodyPr rtlCol="0" anchor="ctr"/>
+          <a:lstStyle/>
+          <a:p>
+            <a:pPr algn="ctr"/>
+          </a:p>
+        </p:txBody>
+      </p:sp>
+      <p:sp>
+        <p:nvSpPr>
+          <p:cNvPr id="9" name="TextBox 8"/>
           <p:cNvSpPr txBox="1"/>
           <p:nvPr/>
         </p:nvSpPr>
         <p:spPr>
           <a:xfrm>
-            <a:off x="548640" y="1234440"/>
-            <a:ext cx="11064240" cy="896112"/>
+            <a:off x="6991502" y="1097280"/>
+            <a:ext cx="4676241" cy="4800599"/>
           </a:xfrm>
           <a:prstGeom prst="rect">
             <a:avLst/>
@@ -4039,20 +5821,20 @@
           <a:noFill/>
         </p:spPr>
         <p:txBody>
-          <a:bodyPr wrap="square" anchor="t" lIns="0" rIns="0" tIns="0" bIns="0">
+          <a:bodyPr wrap="square" anchor="ctr" lIns="0" rIns="0" tIns="0" bIns="0">
             <a:spAutoFit/>
           </a:bodyPr>
           <a:lstStyle/>
           <a:p>
             <a:pPr algn="l"/>
             <a:r>
-              <a:rPr sz="1400" b="0" i="0">
+              <a:rPr sz="1700" b="0" i="0">
                 <a:solidFill>
                   <a:srgbClr val="14141C"/>
                 </a:solidFill>
                 <a:latin typeface="Geist"/>
               </a:rPr>
-              <a:t>Overall accuracy is one number; the confusion matrix shows which mistakes the model actually makes. The diagonal is correct and everything off it is an error, and one column swallows almost everything – the model funnels nearly every spot, cancer or not, into the common harmless-mole class.</a:t>
+              <a:t>Overall accuracy is one number; the confusion matrix shows which mistakes the model actually makes. The diagonal is correct and everything off it is an error, and one column swallows almost everything -- the model funnels nearly every spot, cancer or not, into the common harmless-mole class.</a:t>
             </a:r>
           </a:p>
         </p:txBody>
@@ -4277,16 +6059,84 @@
           </a:p>
         </p:txBody>
       </p:sp>
-      <p:sp>
-        <p:nvSpPr>
-          <p:cNvPr id="7" name="TextBox 6"/>
+      <p:pic>
+        <p:nvPicPr>
+          <p:cNvPr id="7" name="Picture 6" descr="per_class_fairness.png"/>
+          <p:cNvPicPr>
+            <a:picLocks noChangeAspect="1"/>
+          </p:cNvPicPr>
+          <p:nvPr/>
+        </p:nvPicPr>
+        <p:blipFill>
+          <a:blip r:embed="rId2"/>
+          <a:stretch>
+            <a:fillRect/>
+          </a:stretch>
+        </p:blipFill>
+        <p:spPr>
+          <a:xfrm>
+            <a:off x="457200" y="1570418"/>
+            <a:ext cx="6523329" cy="4037203"/>
+          </a:xfrm>
+          <a:prstGeom prst="rect">
+            <a:avLst/>
+          </a:prstGeom>
+        </p:spPr>
+      </p:pic>
+      <p:sp>
+        <p:nvSpPr>
+          <p:cNvPr id="8" name="Rectangle 7"/>
+          <p:cNvSpPr/>
+          <p:nvPr/>
+        </p:nvSpPr>
+        <p:spPr>
+          <a:xfrm>
+            <a:off x="7392009" y="1216152"/>
+            <a:ext cx="73152" cy="4553712"/>
+          </a:xfrm>
+          <a:prstGeom prst="rect">
+            <a:avLst/>
+          </a:prstGeom>
+          <a:solidFill>
+            <a:srgbClr val="F0C840"/>
+          </a:solidFill>
+          <a:ln>
+            <a:noFill/>
+          </a:ln>
+          <a:effectLst/>
+        </p:spPr>
+        <p:style>
+          <a:lnRef idx="1">
+            <a:schemeClr val="accent1"/>
+          </a:lnRef>
+          <a:fillRef idx="3">
+            <a:schemeClr val="accent1"/>
+          </a:fillRef>
+          <a:effectRef idx="2">
+            <a:schemeClr val="accent1"/>
+          </a:effectRef>
+          <a:fontRef idx="minor">
+            <a:schemeClr val="lt1"/>
+          </a:fontRef>
+        </p:style>
+        <p:txBody>
+          <a:bodyPr rtlCol="0" anchor="ctr"/>
+          <a:lstStyle/>
+          <a:p>
+            <a:pPr algn="ctr"/>
+          </a:p>
+        </p:txBody>
+      </p:sp>
+      <p:sp>
+        <p:nvSpPr>
+          <p:cNvPr id="9" name="TextBox 8"/>
           <p:cNvSpPr txBox="1"/>
           <p:nvPr/>
         </p:nvSpPr>
         <p:spPr>
           <a:xfrm>
-            <a:off x="548640" y="1234440"/>
-            <a:ext cx="11064240" cy="896112"/>
+            <a:off x="7666329" y="1097280"/>
+            <a:ext cx="4001414" cy="4800599"/>
           </a:xfrm>
           <a:prstGeom prst="rect">
             <a:avLst/>
@@ -4294,14 +6144,14 @@
           <a:noFill/>
         </p:spPr>
         <p:txBody>
-          <a:bodyPr wrap="square" anchor="t" lIns="0" rIns="0" tIns="0" bIns="0">
+          <a:bodyPr wrap="square" anchor="ctr" lIns="0" rIns="0" tIns="0" bIns="0">
             <a:spAutoFit/>
           </a:bodyPr>
           <a:lstStyle/>
           <a:p>
             <a:pPr algn="l"/>
             <a:r>
-              <a:rPr sz="1400" b="0" i="0">
+              <a:rPr sz="1700" b="0" i="0">
                 <a:solidFill>
                   <a:srgbClr val="14141C"/>
                 </a:solidFill>
@@ -4540,8 +6390,8 @@
         </p:nvSpPr>
         <p:spPr>
           <a:xfrm>
-            <a:off x="548640" y="1234440"/>
-            <a:ext cx="11064240" cy="896112"/>
+            <a:off x="594360" y="1371600"/>
+            <a:ext cx="5173675" cy="411480"/>
           </a:xfrm>
           <a:prstGeom prst="rect">
             <a:avLst/>
@@ -4556,13 +6406,311 @@
           <a:p>
             <a:pPr algn="l"/>
             <a:r>
-              <a:rPr sz="1400" b="0" i="0">
+              <a:rPr sz="1700" b="1" i="0">
+                <a:solidFill>
+                  <a:srgbClr val="FF1493"/>
+                </a:solidFill>
+                <a:latin typeface="Geist Mono"/>
+              </a:rPr>
+              <a:t>MELANOMA RECALL</a:t>
+            </a:r>
+          </a:p>
+        </p:txBody>
+      </p:sp>
+      <p:sp>
+        <p:nvSpPr>
+          <p:cNvPr id="8" name="TextBox 7"/>
+          <p:cNvSpPr txBox="1"/>
+          <p:nvPr/>
+        </p:nvSpPr>
+        <p:spPr>
+          <a:xfrm>
+            <a:off x="457200" y="1709928"/>
+            <a:ext cx="5173675" cy="1737360"/>
+          </a:xfrm>
+          <a:prstGeom prst="rect">
+            <a:avLst/>
+          </a:prstGeom>
+          <a:noFill/>
+        </p:spPr>
+        <p:txBody>
+          <a:bodyPr wrap="square" anchor="t" lIns="0" rIns="0" tIns="0" bIns="0">
+            <a:spAutoFit/>
+          </a:bodyPr>
+          <a:lstStyle/>
+          <a:p>
+            <a:pPr algn="l"/>
+            <a:r>
+              <a:rPr sz="11800" b="1" i="0">
+                <a:solidFill>
+                  <a:srgbClr val="FF1493"/>
+                </a:solidFill>
+                <a:latin typeface="Geist Mono"/>
+              </a:rPr>
+              <a:t>4.5%</a:t>
+            </a:r>
+          </a:p>
+        </p:txBody>
+      </p:sp>
+      <p:sp>
+        <p:nvSpPr>
+          <p:cNvPr id="9" name="TextBox 8"/>
+          <p:cNvSpPr txBox="1"/>
+          <p:nvPr/>
+        </p:nvSpPr>
+        <p:spPr>
+          <a:xfrm>
+            <a:off x="612648" y="3383280"/>
+            <a:ext cx="5173675" cy="365760"/>
+          </a:xfrm>
+          <a:prstGeom prst="rect">
+            <a:avLst/>
+          </a:prstGeom>
+          <a:noFill/>
+        </p:spPr>
+        <p:txBody>
+          <a:bodyPr wrap="square" anchor="t" lIns="0" rIns="0" tIns="0" bIns="0">
+            <a:spAutoFit/>
+          </a:bodyPr>
+          <a:lstStyle/>
+          <a:p>
+            <a:pPr algn="l"/>
+            <a:r>
+              <a:rPr sz="1500" b="0" i="0">
+                <a:solidFill>
+                  <a:srgbClr val="555560"/>
+                </a:solidFill>
+                <a:latin typeface="Geist"/>
+              </a:rPr>
+              <a:t>only 10 of 223 melanomas caught</a:t>
+            </a:r>
+          </a:p>
+        </p:txBody>
+      </p:sp>
+      <p:sp>
+        <p:nvSpPr>
+          <p:cNvPr id="10" name="Rectangle 9"/>
+          <p:cNvSpPr/>
+          <p:nvPr/>
+        </p:nvSpPr>
+        <p:spPr>
+          <a:xfrm>
+            <a:off x="6080760" y="1463040"/>
+            <a:ext cx="18288" cy="2240280"/>
+          </a:xfrm>
+          <a:prstGeom prst="rect">
+            <a:avLst/>
+          </a:prstGeom>
+          <a:solidFill>
+            <a:srgbClr val="DDDDDD"/>
+          </a:solidFill>
+          <a:ln>
+            <a:noFill/>
+          </a:ln>
+          <a:effectLst/>
+        </p:spPr>
+        <p:style>
+          <a:lnRef idx="1">
+            <a:schemeClr val="accent1"/>
+          </a:lnRef>
+          <a:fillRef idx="3">
+            <a:schemeClr val="accent1"/>
+          </a:fillRef>
+          <a:effectRef idx="2">
+            <a:schemeClr val="accent1"/>
+          </a:effectRef>
+          <a:fontRef idx="minor">
+            <a:schemeClr val="lt1"/>
+          </a:fontRef>
+        </p:style>
+        <p:txBody>
+          <a:bodyPr rtlCol="0" anchor="ctr"/>
+          <a:lstStyle/>
+          <a:p>
+            <a:pPr algn="ctr"/>
+          </a:p>
+        </p:txBody>
+      </p:sp>
+      <p:sp>
+        <p:nvSpPr>
+          <p:cNvPr id="11" name="TextBox 10"/>
+          <p:cNvSpPr txBox="1"/>
+          <p:nvPr/>
+        </p:nvSpPr>
+        <p:spPr>
+          <a:xfrm>
+            <a:off x="6586880" y="1371600"/>
+            <a:ext cx="4948732" cy="411480"/>
+          </a:xfrm>
+          <a:prstGeom prst="rect">
+            <a:avLst/>
+          </a:prstGeom>
+          <a:noFill/>
+        </p:spPr>
+        <p:txBody>
+          <a:bodyPr wrap="square" anchor="t" lIns="0" rIns="0" tIns="0" bIns="0">
+            <a:spAutoFit/>
+          </a:bodyPr>
+          <a:lstStyle/>
+          <a:p>
+            <a:pPr algn="l"/>
+            <a:r>
+              <a:rPr sz="1700" b="1" i="0">
+                <a:solidFill>
+                  <a:srgbClr val="14141C"/>
+                </a:solidFill>
+                <a:latin typeface="Geist Mono"/>
+              </a:rPr>
+              <a:t>CANCERS MISSED</a:t>
+            </a:r>
+          </a:p>
+        </p:txBody>
+      </p:sp>
+      <p:sp>
+        <p:nvSpPr>
+          <p:cNvPr id="12" name="TextBox 11"/>
+          <p:cNvSpPr txBox="1"/>
+          <p:nvPr/>
+        </p:nvSpPr>
+        <p:spPr>
+          <a:xfrm>
+            <a:off x="6474409" y="1709928"/>
+            <a:ext cx="4948732" cy="1737360"/>
+          </a:xfrm>
+          <a:prstGeom prst="rect">
+            <a:avLst/>
+          </a:prstGeom>
+          <a:noFill/>
+        </p:spPr>
+        <p:txBody>
+          <a:bodyPr wrap="square" anchor="t" lIns="0" rIns="0" tIns="0" bIns="0">
+            <a:spAutoFit/>
+          </a:bodyPr>
+          <a:lstStyle/>
+          <a:p>
+            <a:pPr algn="l"/>
+            <a:r>
+              <a:rPr sz="11800" b="1" i="0">
+                <a:solidFill>
+                  <a:srgbClr val="14141C"/>
+                </a:solidFill>
+                <a:latin typeface="Geist Mono"/>
+              </a:rPr>
+              <a:t>213</a:t>
+            </a:r>
+          </a:p>
+        </p:txBody>
+      </p:sp>
+      <p:sp>
+        <p:nvSpPr>
+          <p:cNvPr id="13" name="TextBox 12"/>
+          <p:cNvSpPr txBox="1"/>
+          <p:nvPr/>
+        </p:nvSpPr>
+        <p:spPr>
+          <a:xfrm>
+            <a:off x="6586880" y="3383280"/>
+            <a:ext cx="4948732" cy="365760"/>
+          </a:xfrm>
+          <a:prstGeom prst="rect">
+            <a:avLst/>
+          </a:prstGeom>
+          <a:noFill/>
+        </p:spPr>
+        <p:txBody>
+          <a:bodyPr wrap="square" anchor="t" lIns="0" rIns="0" tIns="0" bIns="0">
+            <a:spAutoFit/>
+          </a:bodyPr>
+          <a:lstStyle/>
+          <a:p>
+            <a:pPr algn="l"/>
+            <a:r>
+              <a:rPr sz="1500" b="0" i="0">
+                <a:solidFill>
+                  <a:srgbClr val="555560"/>
+                </a:solidFill>
+                <a:latin typeface="Geist"/>
+              </a:rPr>
+              <a:t>waved through as harmless</a:t>
+            </a:r>
+          </a:p>
+        </p:txBody>
+      </p:sp>
+      <p:sp>
+        <p:nvSpPr>
+          <p:cNvPr id="14" name="Rectangle 13"/>
+          <p:cNvSpPr/>
+          <p:nvPr/>
+        </p:nvSpPr>
+        <p:spPr>
+          <a:xfrm>
+            <a:off x="594360" y="5093207"/>
+            <a:ext cx="10972800" cy="18288"/>
+          </a:xfrm>
+          <a:prstGeom prst="rect">
+            <a:avLst/>
+          </a:prstGeom>
+          <a:solidFill>
+            <a:srgbClr val="F0C840"/>
+          </a:solidFill>
+          <a:ln>
+            <a:noFill/>
+          </a:ln>
+          <a:effectLst/>
+        </p:spPr>
+        <p:style>
+          <a:lnRef idx="1">
+            <a:schemeClr val="accent1"/>
+          </a:lnRef>
+          <a:fillRef idx="3">
+            <a:schemeClr val="accent1"/>
+          </a:fillRef>
+          <a:effectRef idx="2">
+            <a:schemeClr val="accent1"/>
+          </a:effectRef>
+          <a:fontRef idx="minor">
+            <a:schemeClr val="lt1"/>
+          </a:fontRef>
+        </p:style>
+        <p:txBody>
+          <a:bodyPr rtlCol="0" anchor="ctr"/>
+          <a:lstStyle/>
+          <a:p>
+            <a:pPr algn="ctr"/>
+          </a:p>
+        </p:txBody>
+      </p:sp>
+      <p:sp>
+        <p:nvSpPr>
+          <p:cNvPr id="15" name="TextBox 14"/>
+          <p:cNvSpPr txBox="1"/>
+          <p:nvPr/>
+        </p:nvSpPr>
+        <p:spPr>
+          <a:xfrm>
+            <a:off x="594360" y="5212079"/>
+            <a:ext cx="10972800" cy="960120"/>
+          </a:xfrm>
+          <a:prstGeom prst="rect">
+            <a:avLst/>
+          </a:prstGeom>
+          <a:noFill/>
+        </p:spPr>
+        <p:txBody>
+          <a:bodyPr wrap="square" anchor="ctr" lIns="0" rIns="0" tIns="0" bIns="0">
+            <a:spAutoFit/>
+          </a:bodyPr>
+          <a:lstStyle/>
+          <a:p>
+            <a:pPr algn="l"/>
+            <a:r>
+              <a:rPr sz="1800" b="0" i="1">
                 <a:solidFill>
                   <a:srgbClr val="14141C"/>
                 </a:solidFill>
                 <a:latin typeface="Geist"/>
               </a:rPr>
-              <a:t>Here is the sentence that should stop the room. Our model reached sixty-eight percent overall accuracy and still caught only ten of the two hundred twenty-three real melanomas in the test set. It missed two hundred thirteen cancers – proof that a healthy-looking accuracy number can hide a screening tool that is dangerous.</a:t>
+              <a:t>Sixty-eight percent overall accuracy hid a tool that missed almost every cancer. A healthy-looking number can conceal a screening tool that is dangerous.</a:t>
             </a:r>
           </a:p>
         </p:txBody>
@@ -4795,8 +6943,8 @@
         </p:nvSpPr>
         <p:spPr>
           <a:xfrm>
-            <a:off x="548640" y="1234440"/>
-            <a:ext cx="11064240" cy="896112"/>
+            <a:off x="548640" y="1097280"/>
+            <a:ext cx="11064240" cy="1051560"/>
           </a:xfrm>
           <a:prstGeom prst="rect">
             <a:avLst/>
@@ -4811,17 +6959,41 @@
           <a:p>
             <a:pPr algn="l"/>
             <a:r>
-              <a:rPr sz="1400" b="0" i="0">
+              <a:rPr sz="1600" b="0" i="0">
                 <a:solidFill>
                   <a:srgbClr val="14141C"/>
                 </a:solidFill>
                 <a:latin typeface="Geist"/>
               </a:rPr>
-              <a:t>The most revealing slide in any talk is the model’s mistakes. Look at how many true melanomas it labeled as harmless moles: every one of those is a false negative, the exact error a screening tool exists to prevent, and the reason a dermatologist would want a second look at all of them.</a:t>
-            </a:r>
-          </a:p>
-        </p:txBody>
-      </p:sp>
+              <a:t>The most revealing slide in any talk is the model's mistakes. Look how many true melanomas it labeled as harmless moles: every one is a false negative, the exact error a screening tool exists to prevent, and the reason a dermatologist would want a second look at all of them.</a:t>
+            </a:r>
+          </a:p>
+        </p:txBody>
+      </p:sp>
+      <p:pic>
+        <p:nvPicPr>
+          <p:cNvPr id="8" name="Picture 7" descr="failures.png"/>
+          <p:cNvPicPr>
+            <a:picLocks noChangeAspect="1"/>
+          </p:cNvPicPr>
+          <p:nvPr/>
+        </p:nvPicPr>
+        <p:blipFill>
+          <a:blip r:embed="rId2"/>
+          <a:stretch>
+            <a:fillRect/>
+          </a:stretch>
+        </p:blipFill>
+        <p:spPr>
+          <a:xfrm>
+            <a:off x="457200" y="2368459"/>
+            <a:ext cx="11247120" cy="2075361"/>
+          </a:xfrm>
+          <a:prstGeom prst="rect">
+            <a:avLst/>
+          </a:prstGeom>
+        </p:spPr>
+      </p:pic>
     </p:spTree>
   </p:cSld>
   <p:clrMapOvr>
@@ -5497,8 +7669,8 @@
         </p:nvSpPr>
         <p:spPr>
           <a:xfrm>
-            <a:off x="548640" y="1234440"/>
-            <a:ext cx="11064240" cy="1499616"/>
+            <a:off x="457200" y="1051560"/>
+            <a:ext cx="5848502" cy="4846319"/>
           </a:xfrm>
           <a:prstGeom prst="rect">
             <a:avLst/>
@@ -5506,20 +7678,178 @@
           <a:noFill/>
         </p:spPr>
         <p:txBody>
-          <a:bodyPr wrap="square" anchor="t" lIns="0" rIns="0" tIns="0" bIns="0">
+          <a:bodyPr wrap="square" anchor="ctr" lIns="0" rIns="0" tIns="0" bIns="0">
             <a:spAutoFit/>
           </a:bodyPr>
           <a:lstStyle/>
           <a:p>
             <a:pPr algn="l"/>
             <a:r>
-              <a:rPr sz="1400" b="0" i="0">
+              <a:rPr sz="1800" b="0" i="0">
                 <a:solidFill>
                   <a:srgbClr val="14141C"/>
                 </a:solidFill>
                 <a:latin typeface="Geist"/>
               </a:rPr>
-              <a:t>This model is far too small and simple to trust on a real patient: sixty-four-pixel grayscale thumbnails throw away the color and fine texture that dermatologists and real systems rely on, and its melanoma recall is nowhere near safe (Wei 2024). A real tool would train on full-resolution color images, deliberately tune its threshold toward high sensitivity, and be validated across many hospitals first. The point was never the score – it was learning the screening mindset: never miss the dangerous case, and never let a shiny number fool you.</a:t>
+              <a:t>This model is far too small and simple to trust on a real patient: sixty-four-pixel grayscale thumbnails throw away the color and fine texture that dermatologists and real systems rely on, and its melanoma recall is nowhere near safe (Wei 2024). The point was never the score -- it was learning the screening mindset: never miss the dangerous case, and never let a shiny number fool you.</a:t>
+            </a:r>
+          </a:p>
+        </p:txBody>
+      </p:sp>
+      <p:sp>
+        <p:nvSpPr>
+          <p:cNvPr id="8" name="Rectangle 7"/>
+          <p:cNvSpPr/>
+          <p:nvPr/>
+        </p:nvSpPr>
+        <p:spPr>
+          <a:xfrm>
+            <a:off x="6924294" y="2537459"/>
+            <a:ext cx="4780026" cy="1874519"/>
+          </a:xfrm>
+          <a:prstGeom prst="rect">
+            <a:avLst/>
+          </a:prstGeom>
+          <a:solidFill>
+            <a:srgbClr val="FAFAFC"/>
+          </a:solidFill>
+          <a:ln>
+            <a:noFill/>
+          </a:ln>
+          <a:effectLst/>
+        </p:spPr>
+        <p:style>
+          <a:lnRef idx="1">
+            <a:schemeClr val="accent1"/>
+          </a:lnRef>
+          <a:fillRef idx="3">
+            <a:schemeClr val="accent1"/>
+          </a:fillRef>
+          <a:effectRef idx="2">
+            <a:schemeClr val="accent1"/>
+          </a:effectRef>
+          <a:fontRef idx="minor">
+            <a:schemeClr val="lt1"/>
+          </a:fontRef>
+        </p:style>
+        <p:txBody>
+          <a:bodyPr rtlCol="0" anchor="ctr"/>
+          <a:lstStyle/>
+          <a:p>
+            <a:pPr algn="ctr"/>
+          </a:p>
+        </p:txBody>
+      </p:sp>
+      <p:sp>
+        <p:nvSpPr>
+          <p:cNvPr id="9" name="Rectangle 8"/>
+          <p:cNvSpPr/>
+          <p:nvPr/>
+        </p:nvSpPr>
+        <p:spPr>
+          <a:xfrm>
+            <a:off x="6924294" y="2537459"/>
+            <a:ext cx="4780026" cy="54864"/>
+          </a:xfrm>
+          <a:prstGeom prst="rect">
+            <a:avLst/>
+          </a:prstGeom>
+          <a:solidFill>
+            <a:srgbClr val="8A2BE2"/>
+          </a:solidFill>
+          <a:ln>
+            <a:noFill/>
+          </a:ln>
+          <a:effectLst/>
+        </p:spPr>
+        <p:style>
+          <a:lnRef idx="1">
+            <a:schemeClr val="accent1"/>
+          </a:lnRef>
+          <a:fillRef idx="3">
+            <a:schemeClr val="accent1"/>
+          </a:fillRef>
+          <a:effectRef idx="2">
+            <a:schemeClr val="accent1"/>
+          </a:effectRef>
+          <a:fontRef idx="minor">
+            <a:schemeClr val="lt1"/>
+          </a:fontRef>
+        </p:style>
+        <p:txBody>
+          <a:bodyPr rtlCol="0" anchor="ctr"/>
+          <a:lstStyle/>
+          <a:p>
+            <a:pPr algn="ctr"/>
+          </a:p>
+        </p:txBody>
+      </p:sp>
+      <p:sp>
+        <p:nvSpPr>
+          <p:cNvPr id="10" name="TextBox 9"/>
+          <p:cNvSpPr txBox="1"/>
+          <p:nvPr/>
+        </p:nvSpPr>
+        <p:spPr>
+          <a:xfrm>
+            <a:off x="7088886" y="2628899"/>
+            <a:ext cx="4450842" cy="384048"/>
+          </a:xfrm>
+          <a:prstGeom prst="rect">
+            <a:avLst/>
+          </a:prstGeom>
+          <a:noFill/>
+        </p:spPr>
+        <p:txBody>
+          <a:bodyPr wrap="square" anchor="t" lIns="0" rIns="0" tIns="0" bIns="0">
+            <a:spAutoFit/>
+          </a:bodyPr>
+          <a:lstStyle/>
+          <a:p>
+            <a:pPr algn="l"/>
+            <a:r>
+              <a:rPr sz="1400" b="1" i="0">
+                <a:solidFill>
+                  <a:srgbClr val="8A2BE2"/>
+                </a:solidFill>
+                <a:latin typeface="Geist Mono"/>
+              </a:rPr>
+              <a:t>A REAL TOOL WOULD</a:t>
+            </a:r>
+          </a:p>
+        </p:txBody>
+      </p:sp>
+      <p:sp>
+        <p:nvSpPr>
+          <p:cNvPr id="11" name="TextBox 10"/>
+          <p:cNvSpPr txBox="1"/>
+          <p:nvPr/>
+        </p:nvSpPr>
+        <p:spPr>
+          <a:xfrm>
+            <a:off x="7088886" y="3177539"/>
+            <a:ext cx="4450842" cy="1142999"/>
+          </a:xfrm>
+          <a:prstGeom prst="rect">
+            <a:avLst/>
+          </a:prstGeom>
+          <a:noFill/>
+        </p:spPr>
+        <p:txBody>
+          <a:bodyPr wrap="square" anchor="t" lIns="0" rIns="0" tIns="0" bIns="0">
+            <a:spAutoFit/>
+          </a:bodyPr>
+          <a:lstStyle/>
+          <a:p>
+            <a:pPr algn="l"/>
+            <a:r>
+              <a:rPr sz="1200" b="0" i="0">
+                <a:solidFill>
+                  <a:srgbClr val="14141C"/>
+                </a:solidFill>
+                <a:latin typeface="Geist"/>
+              </a:rPr>
+              <a:t>Train on full-resolution color images. Deliberately tune its threshold toward high sensitivity. Be validated across many hospitals before it ever sees a patient.</a:t>
             </a:r>
           </a:p>
         </p:txBody>
@@ -5752,8 +8082,8 @@
         </p:nvSpPr>
         <p:spPr>
           <a:xfrm>
-            <a:off x="548640" y="1234440"/>
-            <a:ext cx="11064240" cy="694944"/>
+            <a:off x="502920" y="1051560"/>
+            <a:ext cx="11247120" cy="365760"/>
           </a:xfrm>
           <a:prstGeom prst="rect">
             <a:avLst/>
@@ -5768,13 +8098,167 @@
           <a:p>
             <a:pPr algn="l"/>
             <a:r>
-              <a:rPr sz="1400" b="0" i="0">
+              <a:rPr sz="1500" b="1" i="0">
+                <a:solidFill>
+                  <a:srgbClr val="8A2BE2"/>
+                </a:solidFill>
+                <a:latin typeface="Geist Mono"/>
+              </a:rPr>
+              <a:t>SEVEN PAPERS GROUNDED THIS PROJECT</a:t>
+            </a:r>
+          </a:p>
+        </p:txBody>
+      </p:sp>
+      <p:sp>
+        <p:nvSpPr>
+          <p:cNvPr id="8" name="TextBox 7"/>
+          <p:cNvSpPr txBox="1"/>
+          <p:nvPr/>
+        </p:nvSpPr>
+        <p:spPr>
+          <a:xfrm>
+            <a:off x="502920" y="1600200"/>
+            <a:ext cx="5398617" cy="3657599"/>
+          </a:xfrm>
+          <a:prstGeom prst="rect">
+            <a:avLst/>
+          </a:prstGeom>
+          <a:noFill/>
+        </p:spPr>
+        <p:txBody>
+          <a:bodyPr wrap="square" anchor="t" lIns="0" rIns="0" tIns="0" bIns="0">
+            <a:spAutoFit/>
+          </a:bodyPr>
+          <a:lstStyle/>
+          <a:p>
+            <a:pPr algn="l"/>
+            <a:r>
+              <a:rPr sz="1300" b="0" i="0">
                 <a:solidFill>
                   <a:srgbClr val="14141C"/>
                 </a:solidFill>
                 <a:latin typeface="Geist"/>
               </a:rPr>
-              <a:t>Seven papers grounded this project, from the dermatologist-level results that started the field to the plain-language guide on why sensitivity matters. Thank you for watching – go build something you can honestly evaluate.</a:t>
+              <a:t>[1] Esteva et al. 2017 -- Dermatologist-level classification of skin cancer with deep neural networks. Nature.
+[2] Tschandl et al. 2018 -- The HAM10000 dermatoscopy dataset. Scientific Data.
+[3] Haenssle et al. 2018 -- Man against machine: a CNN vs 58 dermatologists. Annals of Oncology.
+[4] Tschandl et al. 2019 -- Human readers vs machine learning for pigmented lesions. Lancet Oncology.</a:t>
+            </a:r>
+          </a:p>
+        </p:txBody>
+      </p:sp>
+      <p:sp>
+        <p:nvSpPr>
+          <p:cNvPr id="9" name="TextBox 8"/>
+          <p:cNvSpPr txBox="1"/>
+          <p:nvPr/>
+        </p:nvSpPr>
+        <p:spPr>
+          <a:xfrm>
+            <a:off x="6305702" y="1600200"/>
+            <a:ext cx="5173675" cy="3657599"/>
+          </a:xfrm>
+          <a:prstGeom prst="rect">
+            <a:avLst/>
+          </a:prstGeom>
+          <a:noFill/>
+        </p:spPr>
+        <p:txBody>
+          <a:bodyPr wrap="square" anchor="t" lIns="0" rIns="0" tIns="0" bIns="0">
+            <a:spAutoFit/>
+          </a:bodyPr>
+          <a:lstStyle/>
+          <a:p>
+            <a:pPr algn="l"/>
+            <a:r>
+              <a:rPr sz="1300" b="0" i="0">
+                <a:solidFill>
+                  <a:srgbClr val="14141C"/>
+                </a:solidFill>
+                <a:latin typeface="Geist"/>
+              </a:rPr>
+              <a:t>[5] Kim et al. 2022 -- Transfer learning for medical image classification: a review. BMC Medical Imaging.
+[6] Trevethan 2017 -- Sensitivity, specificity, and predictive values. Frontiers in Public Health.
+[7] Wei et al. 2024 -- Artificial intelligence and skin cancer. Frontiers in Medicine.</a:t>
+            </a:r>
+          </a:p>
+        </p:txBody>
+      </p:sp>
+      <p:sp>
+        <p:nvSpPr>
+          <p:cNvPr id="10" name="Rectangle 9"/>
+          <p:cNvSpPr/>
+          <p:nvPr/>
+        </p:nvSpPr>
+        <p:spPr>
+          <a:xfrm>
+            <a:off x="502920" y="5532120"/>
+            <a:ext cx="11155680" cy="18288"/>
+          </a:xfrm>
+          <a:prstGeom prst="rect">
+            <a:avLst/>
+          </a:prstGeom>
+          <a:solidFill>
+            <a:srgbClr val="8A2BE2"/>
+          </a:solidFill>
+          <a:ln>
+            <a:noFill/>
+          </a:ln>
+          <a:effectLst/>
+        </p:spPr>
+        <p:style>
+          <a:lnRef idx="1">
+            <a:schemeClr val="accent1"/>
+          </a:lnRef>
+          <a:fillRef idx="3">
+            <a:schemeClr val="accent1"/>
+          </a:fillRef>
+          <a:effectRef idx="2">
+            <a:schemeClr val="accent1"/>
+          </a:effectRef>
+          <a:fontRef idx="minor">
+            <a:schemeClr val="lt1"/>
+          </a:fontRef>
+        </p:style>
+        <p:txBody>
+          <a:bodyPr rtlCol="0" anchor="ctr"/>
+          <a:lstStyle/>
+          <a:p>
+            <a:pPr algn="ctr"/>
+          </a:p>
+        </p:txBody>
+      </p:sp>
+      <p:sp>
+        <p:nvSpPr>
+          <p:cNvPr id="11" name="TextBox 10"/>
+          <p:cNvSpPr txBox="1"/>
+          <p:nvPr/>
+        </p:nvSpPr>
+        <p:spPr>
+          <a:xfrm>
+            <a:off x="502920" y="5660136"/>
+            <a:ext cx="11155680" cy="502920"/>
+          </a:xfrm>
+          <a:prstGeom prst="rect">
+            <a:avLst/>
+          </a:prstGeom>
+          <a:noFill/>
+        </p:spPr>
+        <p:txBody>
+          <a:bodyPr wrap="square" anchor="t" lIns="0" rIns="0" tIns="0" bIns="0">
+            <a:spAutoFit/>
+          </a:bodyPr>
+          <a:lstStyle/>
+          <a:p>
+            <a:pPr algn="l"/>
+            <a:r>
+              <a:rPr sz="1800" b="1" i="0">
+                <a:solidFill>
+                  <a:srgbClr val="14141C"/>
+                </a:solidFill>
+                <a:latin typeface="Geist Mono"/>
+              </a:rPr>
+              <a:t>Thank you for watching  --  go build something you can honestly evaluate.</a:t>
             </a:r>
           </a:p>
         </p:txBody>
@@ -6827,16 +9311,84 @@
           </a:p>
         </p:txBody>
       </p:sp>
-      <p:sp>
-        <p:nvSpPr>
-          <p:cNvPr id="7" name="TextBox 6"/>
+      <p:pic>
+        <p:nvPicPr>
+          <p:cNvPr id="7" name="Picture 6" descr="intro_cost_of_a_miss.png"/>
+          <p:cNvPicPr>
+            <a:picLocks noChangeAspect="1"/>
+          </p:cNvPicPr>
+          <p:nvPr/>
+        </p:nvPicPr>
+        <p:blipFill>
+          <a:blip r:embed="rId2"/>
+          <a:stretch>
+            <a:fillRect/>
+          </a:stretch>
+        </p:blipFill>
+        <p:spPr>
+          <a:xfrm>
+            <a:off x="457200" y="1367105"/>
+            <a:ext cx="5623560" cy="4443829"/>
+          </a:xfrm>
+          <a:prstGeom prst="rect">
+            <a:avLst/>
+          </a:prstGeom>
+        </p:spPr>
+      </p:pic>
+      <p:sp>
+        <p:nvSpPr>
+          <p:cNvPr id="8" name="Rectangle 7"/>
+          <p:cNvSpPr/>
+          <p:nvPr/>
+        </p:nvSpPr>
+        <p:spPr>
+          <a:xfrm>
+            <a:off x="6492240" y="1216152"/>
+            <a:ext cx="73152" cy="4553712"/>
+          </a:xfrm>
+          <a:prstGeom prst="rect">
+            <a:avLst/>
+          </a:prstGeom>
+          <a:solidFill>
+            <a:srgbClr val="40E0D0"/>
+          </a:solidFill>
+          <a:ln>
+            <a:noFill/>
+          </a:ln>
+          <a:effectLst/>
+        </p:spPr>
+        <p:style>
+          <a:lnRef idx="1">
+            <a:schemeClr val="accent1"/>
+          </a:lnRef>
+          <a:fillRef idx="3">
+            <a:schemeClr val="accent1"/>
+          </a:fillRef>
+          <a:effectRef idx="2">
+            <a:schemeClr val="accent1"/>
+          </a:effectRef>
+          <a:fontRef idx="minor">
+            <a:schemeClr val="lt1"/>
+          </a:fontRef>
+        </p:style>
+        <p:txBody>
+          <a:bodyPr rtlCol="0" anchor="ctr"/>
+          <a:lstStyle/>
+          <a:p>
+            <a:pPr algn="ctr"/>
+          </a:p>
+        </p:txBody>
+      </p:sp>
+      <p:sp>
+        <p:nvSpPr>
+          <p:cNvPr id="9" name="TextBox 8"/>
           <p:cNvSpPr txBox="1"/>
           <p:nvPr/>
         </p:nvSpPr>
         <p:spPr>
           <a:xfrm>
-            <a:off x="548640" y="1234440"/>
-            <a:ext cx="11064240" cy="1097280"/>
+            <a:off x="6766560" y="1097280"/>
+            <a:ext cx="4901184" cy="4800599"/>
           </a:xfrm>
           <a:prstGeom prst="rect">
             <a:avLst/>
@@ -6844,20 +9396,20 @@
           <a:noFill/>
         </p:spPr>
         <p:txBody>
-          <a:bodyPr wrap="square" anchor="t" lIns="0" rIns="0" tIns="0" bIns="0">
+          <a:bodyPr wrap="square" anchor="ctr" lIns="0" rIns="0" tIns="0" bIns="0">
             <a:spAutoFit/>
           </a:bodyPr>
           <a:lstStyle/>
           <a:p>
             <a:pPr algn="l"/>
             <a:r>
-              <a:rPr sz="1400" b="0" i="0">
+              <a:rPr sz="1700" b="0" i="0">
                 <a:solidFill>
                   <a:srgbClr val="14141C"/>
                 </a:solidFill>
                 <a:latin typeface="Geist"/>
               </a:rPr>
-              <a:t>Dermatology-AI systems look at a photo of a skin spot and estimate how likely it is to be cancer, and landmark studies showed a neural network can match or beat dermatologists at exactly this task (Esteva 2017, Haenssle 2018). But for a screening tool the goal is not to be right on average – it is to never wave a real melanoma through as harmless, because that missed cancer is the one mistake that can kill.</a:t>
+              <a:t>Dermatology-AI looks at a photo of a skin spot and estimates how likely it is to be cancer, and landmark studies showed a neural network can match or beat dermatologists at exactly this task (Esteva 2017, Haenssle 2018). But for a screening tool the goal is not to be right on average -- it is to never wave a real melanoma through as harmless, because that missed cancer is the one mistake that can kill.</a:t>
             </a:r>
           </a:p>
         </p:txBody>
@@ -7082,16 +9634,84 @@
           </a:p>
         </p:txBody>
       </p:sp>
-      <p:sp>
-        <p:nvSpPr>
-          <p:cNvPr id="7" name="TextBox 6"/>
+      <p:pic>
+        <p:nvPicPr>
+          <p:cNvPr id="7" name="Picture 6" descr="intro_sensitivity_tradeoff.png"/>
+          <p:cNvPicPr>
+            <a:picLocks noChangeAspect="1"/>
+          </p:cNvPicPr>
+          <p:nvPr/>
+        </p:nvPicPr>
+        <p:blipFill>
+          <a:blip r:embed="rId2"/>
+          <a:stretch>
+            <a:fillRect/>
+          </a:stretch>
+        </p:blipFill>
+        <p:spPr>
+          <a:xfrm>
+            <a:off x="457200" y="1534562"/>
+            <a:ext cx="6523329" cy="4108914"/>
+          </a:xfrm>
+          <a:prstGeom prst="rect">
+            <a:avLst/>
+          </a:prstGeom>
+        </p:spPr>
+      </p:pic>
+      <p:sp>
+        <p:nvSpPr>
+          <p:cNvPr id="8" name="Rectangle 7"/>
+          <p:cNvSpPr/>
+          <p:nvPr/>
+        </p:nvSpPr>
+        <p:spPr>
+          <a:xfrm>
+            <a:off x="7392009" y="1216152"/>
+            <a:ext cx="73152" cy="4553712"/>
+          </a:xfrm>
+          <a:prstGeom prst="rect">
+            <a:avLst/>
+          </a:prstGeom>
+          <a:solidFill>
+            <a:srgbClr val="40E0D0"/>
+          </a:solidFill>
+          <a:ln>
+            <a:noFill/>
+          </a:ln>
+          <a:effectLst/>
+        </p:spPr>
+        <p:style>
+          <a:lnRef idx="1">
+            <a:schemeClr val="accent1"/>
+          </a:lnRef>
+          <a:fillRef idx="3">
+            <a:schemeClr val="accent1"/>
+          </a:fillRef>
+          <a:effectRef idx="2">
+            <a:schemeClr val="accent1"/>
+          </a:effectRef>
+          <a:fontRef idx="minor">
+            <a:schemeClr val="lt1"/>
+          </a:fontRef>
+        </p:style>
+        <p:txBody>
+          <a:bodyPr rtlCol="0" anchor="ctr"/>
+          <a:lstStyle/>
+          <a:p>
+            <a:pPr algn="ctr"/>
+          </a:p>
+        </p:txBody>
+      </p:sp>
+      <p:sp>
+        <p:nvSpPr>
+          <p:cNvPr id="9" name="TextBox 8"/>
           <p:cNvSpPr txBox="1"/>
           <p:nvPr/>
         </p:nvSpPr>
         <p:spPr>
           <a:xfrm>
-            <a:off x="548640" y="1234440"/>
-            <a:ext cx="11064240" cy="1097280"/>
+            <a:off x="7666329" y="1097280"/>
+            <a:ext cx="4001414" cy="4800599"/>
           </a:xfrm>
           <a:prstGeom prst="rect">
             <a:avLst/>
@@ -7099,20 +9719,20 @@
           <a:noFill/>
         </p:spPr>
         <p:txBody>
-          <a:bodyPr wrap="square" anchor="t" lIns="0" rIns="0" tIns="0" bIns="0">
+          <a:bodyPr wrap="square" anchor="ctr" lIns="0" rIns="0" tIns="0" bIns="0">
             <a:spAutoFit/>
           </a:bodyPr>
           <a:lstStyle/>
           <a:p>
             <a:pPr algn="l"/>
             <a:r>
-              <a:rPr sz="1400" b="0" i="0">
+              <a:rPr sz="1700" b="0" i="0">
                 <a:solidFill>
                   <a:srgbClr val="14141C"/>
                 </a:solidFill>
                 <a:latin typeface="Geist"/>
               </a:rPr>
-              <a:t>Every screening model has a decision threshold, and where you set it is a trade-off you cannot escape. Slide it one way and you catch more cancers but raise more false alarms; slide it the other way and you calm the false alarms but start missing real disease. Screening deliberately favors sensitivity – catching the cancers – because a false alarm just costs a follow-up visit (Trevethan 2017).</a:t>
+              <a:t>Every screening model has a decision threshold, and where you set it is a trade-off you cannot escape. Slide it one way and you catch more cancers but raise more false alarms; slide it the other way and you calm the false alarms but start missing real disease. Screening deliberately favors sensitivity -- catching the cancers -- because a false alarm just costs a follow-up visit (Trevethan 2017).</a:t>
             </a:r>
           </a:p>
         </p:txBody>
@@ -7337,16 +9957,84 @@
           </a:p>
         </p:txBody>
       </p:sp>
-      <p:sp>
-        <p:nvSpPr>
-          <p:cNvPr id="7" name="TextBox 6"/>
+      <p:pic>
+        <p:nvPicPr>
+          <p:cNvPr id="7" name="Picture 6" descr="intro_transfer_learning.png"/>
+          <p:cNvPicPr>
+            <a:picLocks noChangeAspect="1"/>
+          </p:cNvPicPr>
+          <p:nvPr/>
+        </p:nvPicPr>
+        <p:blipFill>
+          <a:blip r:embed="rId2"/>
+          <a:stretch>
+            <a:fillRect/>
+          </a:stretch>
+        </p:blipFill>
+        <p:spPr>
+          <a:xfrm>
+            <a:off x="2230856" y="1097280"/>
+            <a:ext cx="7699806" cy="3023006"/>
+          </a:xfrm>
+          <a:prstGeom prst="rect">
+            <a:avLst/>
+          </a:prstGeom>
+        </p:spPr>
+      </p:pic>
+      <p:sp>
+        <p:nvSpPr>
+          <p:cNvPr id="8" name="Rectangle 7"/>
+          <p:cNvSpPr/>
+          <p:nvPr/>
+        </p:nvSpPr>
+        <p:spPr>
+          <a:xfrm>
+            <a:off x="475488" y="4257446"/>
+            <a:ext cx="73152" cy="1869033"/>
+          </a:xfrm>
+          <a:prstGeom prst="rect">
+            <a:avLst/>
+          </a:prstGeom>
+          <a:solidFill>
+            <a:srgbClr val="40E0D0"/>
+          </a:solidFill>
+          <a:ln>
+            <a:noFill/>
+          </a:ln>
+          <a:effectLst/>
+        </p:spPr>
+        <p:style>
+          <a:lnRef idx="1">
+            <a:schemeClr val="accent1"/>
+          </a:lnRef>
+          <a:fillRef idx="3">
+            <a:schemeClr val="accent1"/>
+          </a:fillRef>
+          <a:effectRef idx="2">
+            <a:schemeClr val="accent1"/>
+          </a:effectRef>
+          <a:fontRef idx="minor">
+            <a:schemeClr val="lt1"/>
+          </a:fontRef>
+        </p:style>
+        <p:txBody>
+          <a:bodyPr rtlCol="0" anchor="ctr"/>
+          <a:lstStyle/>
+          <a:p>
+            <a:pPr algn="ctr"/>
+          </a:p>
+        </p:txBody>
+      </p:sp>
+      <p:sp>
+        <p:nvSpPr>
+          <p:cNvPr id="9" name="TextBox 8"/>
           <p:cNvSpPr txBox="1"/>
           <p:nvPr/>
         </p:nvSpPr>
         <p:spPr>
           <a:xfrm>
-            <a:off x="548640" y="1234440"/>
-            <a:ext cx="11064240" cy="1097280"/>
+            <a:off x="731520" y="4184294"/>
+            <a:ext cx="10789920" cy="2051913"/>
           </a:xfrm>
           <a:prstGeom prst="rect">
             <a:avLst/>
@@ -7354,14 +10042,14 @@
           <a:noFill/>
         </p:spPr>
         <p:txBody>
-          <a:bodyPr wrap="square" anchor="t" lIns="0" rIns="0" tIns="0" bIns="0">
+          <a:bodyPr wrap="square" anchor="ctr" lIns="0" rIns="0" tIns="0" bIns="0">
             <a:spAutoFit/>
           </a:bodyPr>
           <a:lstStyle/>
           <a:p>
             <a:pPr algn="l"/>
             <a:r>
-              <a:rPr sz="1400" b="0" i="0">
+              <a:rPr sz="1600" b="0" i="0">
                 <a:solidFill>
                   <a:srgbClr val="14141C"/>
                 </a:solidFill>
@@ -8047,8 +10735,8 @@
         </p:nvSpPr>
         <p:spPr>
           <a:xfrm>
-            <a:off x="548640" y="1234440"/>
-            <a:ext cx="11064240" cy="896112"/>
+            <a:off x="457200" y="1051560"/>
+            <a:ext cx="5848502" cy="4846319"/>
           </a:xfrm>
           <a:prstGeom prst="rect">
             <a:avLst/>
@@ -8056,20 +10744,178 @@
           <a:noFill/>
         </p:spPr>
         <p:txBody>
-          <a:bodyPr wrap="square" anchor="t" lIns="0" rIns="0" tIns="0" bIns="0">
+          <a:bodyPr wrap="square" anchor="ctr" lIns="0" rIns="0" tIns="0" bIns="0">
             <a:spAutoFit/>
           </a:bodyPr>
           <a:lstStyle/>
           <a:p>
             <a:pPr algn="l"/>
             <a:r>
-              <a:rPr sz="1400" b="0" i="0">
+              <a:rPr sz="1800" b="0" i="0">
                 <a:solidFill>
                   <a:srgbClr val="14141C"/>
                 </a:solidFill>
                 <a:latin typeface="Geist"/>
               </a:rPr>
-              <a:t>Our data is DermaMNIST, a tidy version of the HAM10000 dermatoscopy collection with seven lesion types, including melanoma (Tschandl 2018). The catch is severe imbalance: harmless moles make up about two-thirds of every set, and melanoma is a small slice – which is precisely the setup where a lazy model can look accurate while catching zero cancers.</a:t>
+              <a:t>Our data is DermaMNIST, a tidy version of the HAM10000 dermatoscopy collection with seven kinds of skin lesion, one of which is melanoma -- the class we cannot afford to miss (Tschandl 2018).</a:t>
+            </a:r>
+          </a:p>
+        </p:txBody>
+      </p:sp>
+      <p:sp>
+        <p:nvSpPr>
+          <p:cNvPr id="8" name="Rectangle 7"/>
+          <p:cNvSpPr/>
+          <p:nvPr/>
+        </p:nvSpPr>
+        <p:spPr>
+          <a:xfrm>
+            <a:off x="6924294" y="2537459"/>
+            <a:ext cx="4780026" cy="1874519"/>
+          </a:xfrm>
+          <a:prstGeom prst="rect">
+            <a:avLst/>
+          </a:prstGeom>
+          <a:solidFill>
+            <a:srgbClr val="FAFAFC"/>
+          </a:solidFill>
+          <a:ln>
+            <a:noFill/>
+          </a:ln>
+          <a:effectLst/>
+        </p:spPr>
+        <p:style>
+          <a:lnRef idx="1">
+            <a:schemeClr val="accent1"/>
+          </a:lnRef>
+          <a:fillRef idx="3">
+            <a:schemeClr val="accent1"/>
+          </a:fillRef>
+          <a:effectRef idx="2">
+            <a:schemeClr val="accent1"/>
+          </a:effectRef>
+          <a:fontRef idx="minor">
+            <a:schemeClr val="lt1"/>
+          </a:fontRef>
+        </p:style>
+        <p:txBody>
+          <a:bodyPr rtlCol="0" anchor="ctr"/>
+          <a:lstStyle/>
+          <a:p>
+            <a:pPr algn="ctr"/>
+          </a:p>
+        </p:txBody>
+      </p:sp>
+      <p:sp>
+        <p:nvSpPr>
+          <p:cNvPr id="9" name="Rectangle 8"/>
+          <p:cNvSpPr/>
+          <p:nvPr/>
+        </p:nvSpPr>
+        <p:spPr>
+          <a:xfrm>
+            <a:off x="6924294" y="2537459"/>
+            <a:ext cx="4780026" cy="54864"/>
+          </a:xfrm>
+          <a:prstGeom prst="rect">
+            <a:avLst/>
+          </a:prstGeom>
+          <a:solidFill>
+            <a:srgbClr val="FF1493"/>
+          </a:solidFill>
+          <a:ln>
+            <a:noFill/>
+          </a:ln>
+          <a:effectLst/>
+        </p:spPr>
+        <p:style>
+          <a:lnRef idx="1">
+            <a:schemeClr val="accent1"/>
+          </a:lnRef>
+          <a:fillRef idx="3">
+            <a:schemeClr val="accent1"/>
+          </a:fillRef>
+          <a:effectRef idx="2">
+            <a:schemeClr val="accent1"/>
+          </a:effectRef>
+          <a:fontRef idx="minor">
+            <a:schemeClr val="lt1"/>
+          </a:fontRef>
+        </p:style>
+        <p:txBody>
+          <a:bodyPr rtlCol="0" anchor="ctr"/>
+          <a:lstStyle/>
+          <a:p>
+            <a:pPr algn="ctr"/>
+          </a:p>
+        </p:txBody>
+      </p:sp>
+      <p:sp>
+        <p:nvSpPr>
+          <p:cNvPr id="10" name="TextBox 9"/>
+          <p:cNvSpPr txBox="1"/>
+          <p:nvPr/>
+        </p:nvSpPr>
+        <p:spPr>
+          <a:xfrm>
+            <a:off x="7088886" y="2628899"/>
+            <a:ext cx="4450842" cy="384048"/>
+          </a:xfrm>
+          <a:prstGeom prst="rect">
+            <a:avLst/>
+          </a:prstGeom>
+          <a:noFill/>
+        </p:spPr>
+        <p:txBody>
+          <a:bodyPr wrap="square" anchor="t" lIns="0" rIns="0" tIns="0" bIns="0">
+            <a:spAutoFit/>
+          </a:bodyPr>
+          <a:lstStyle/>
+          <a:p>
+            <a:pPr algn="l"/>
+            <a:r>
+              <a:rPr sz="1400" b="1" i="0">
+                <a:solidFill>
+                  <a:srgbClr val="FF1493"/>
+                </a:solidFill>
+                <a:latin typeface="Geist Mono"/>
+              </a:rPr>
+              <a:t>THE CATCH  --  IMBALANCE</a:t>
+            </a:r>
+          </a:p>
+        </p:txBody>
+      </p:sp>
+      <p:sp>
+        <p:nvSpPr>
+          <p:cNvPr id="11" name="TextBox 10"/>
+          <p:cNvSpPr txBox="1"/>
+          <p:nvPr/>
+        </p:nvSpPr>
+        <p:spPr>
+          <a:xfrm>
+            <a:off x="7088886" y="3177539"/>
+            <a:ext cx="4450842" cy="1142999"/>
+          </a:xfrm>
+          <a:prstGeom prst="rect">
+            <a:avLst/>
+          </a:prstGeom>
+          <a:noFill/>
+        </p:spPr>
+        <p:txBody>
+          <a:bodyPr wrap="square" anchor="t" lIns="0" rIns="0" tIns="0" bIns="0">
+            <a:spAutoFit/>
+          </a:bodyPr>
+          <a:lstStyle/>
+          <a:p>
+            <a:pPr algn="l"/>
+            <a:r>
+              <a:rPr sz="1200" b="0" i="0">
+                <a:solidFill>
+                  <a:srgbClr val="14141C"/>
+                </a:solidFill>
+                <a:latin typeface="Geist"/>
+              </a:rPr>
+              <a:t>About two-thirds of every set is harmless moles. Melanoma is only a thin slice -- exactly the setup where a lazy model can look accurate while catching almost no cancers.</a:t>
             </a:r>
           </a:p>
         </p:txBody>
@@ -8302,8 +11148,8 @@
         </p:nvSpPr>
         <p:spPr>
           <a:xfrm>
-            <a:off x="548640" y="1234440"/>
-            <a:ext cx="11064240" cy="896112"/>
+            <a:off x="457200" y="1051560"/>
+            <a:ext cx="5848502" cy="4846319"/>
           </a:xfrm>
           <a:prstGeom prst="rect">
             <a:avLst/>
@@ -8311,20 +11157,178 @@
           <a:noFill/>
         </p:spPr>
         <p:txBody>
-          <a:bodyPr wrap="square" anchor="t" lIns="0" rIns="0" tIns="0" bIns="0">
+          <a:bodyPr wrap="square" anchor="ctr" lIns="0" rIns="0" tIns="0" bIns="0">
             <a:spAutoFit/>
           </a:bodyPr>
           <a:lstStyle/>
           <a:p>
             <a:pPr algn="l"/>
             <a:r>
-              <a:rPr sz="1400" b="0" i="0">
+              <a:rPr sz="1800" b="0" i="0">
                 <a:solidFill>
                   <a:srgbClr val="14141C"/>
                 </a:solidFill>
                 <a:latin typeface="Geist"/>
               </a:rPr>
-              <a:t>We trained the network three ways – from scratch, pretrained, and pretrained with augmentation – and then audited the best one the way a regulator would. We did not grade on accuracy alone; we tracked melanoma recall, the share of true melanomas actually caught, because on this data that single number decides whether the tool is safe.</a:t>
+              <a:t>We trained the network three ways -- from scratch, pretrained, and pretrained with augmentation -- and then audited the best one the way a regulator would, refusing to grade on accuracy alone.</a:t>
+            </a:r>
+          </a:p>
+        </p:txBody>
+      </p:sp>
+      <p:sp>
+        <p:nvSpPr>
+          <p:cNvPr id="8" name="Rectangle 7"/>
+          <p:cNvSpPr/>
+          <p:nvPr/>
+        </p:nvSpPr>
+        <p:spPr>
+          <a:xfrm>
+            <a:off x="6924294" y="2537459"/>
+            <a:ext cx="4780026" cy="1874519"/>
+          </a:xfrm>
+          <a:prstGeom prst="rect">
+            <a:avLst/>
+          </a:prstGeom>
+          <a:solidFill>
+            <a:srgbClr val="FAFAFC"/>
+          </a:solidFill>
+          <a:ln>
+            <a:noFill/>
+          </a:ln>
+          <a:effectLst/>
+        </p:spPr>
+        <p:style>
+          <a:lnRef idx="1">
+            <a:schemeClr val="accent1"/>
+          </a:lnRef>
+          <a:fillRef idx="3">
+            <a:schemeClr val="accent1"/>
+          </a:fillRef>
+          <a:effectRef idx="2">
+            <a:schemeClr val="accent1"/>
+          </a:effectRef>
+          <a:fontRef idx="minor">
+            <a:schemeClr val="lt1"/>
+          </a:fontRef>
+        </p:style>
+        <p:txBody>
+          <a:bodyPr rtlCol="0" anchor="ctr"/>
+          <a:lstStyle/>
+          <a:p>
+            <a:pPr algn="ctr"/>
+          </a:p>
+        </p:txBody>
+      </p:sp>
+      <p:sp>
+        <p:nvSpPr>
+          <p:cNvPr id="9" name="Rectangle 8"/>
+          <p:cNvSpPr/>
+          <p:nvPr/>
+        </p:nvSpPr>
+        <p:spPr>
+          <a:xfrm>
+            <a:off x="6924294" y="2537459"/>
+            <a:ext cx="4780026" cy="54864"/>
+          </a:xfrm>
+          <a:prstGeom prst="rect">
+            <a:avLst/>
+          </a:prstGeom>
+          <a:solidFill>
+            <a:srgbClr val="FF1493"/>
+          </a:solidFill>
+          <a:ln>
+            <a:noFill/>
+          </a:ln>
+          <a:effectLst/>
+        </p:spPr>
+        <p:style>
+          <a:lnRef idx="1">
+            <a:schemeClr val="accent1"/>
+          </a:lnRef>
+          <a:fillRef idx="3">
+            <a:schemeClr val="accent1"/>
+          </a:fillRef>
+          <a:effectRef idx="2">
+            <a:schemeClr val="accent1"/>
+          </a:effectRef>
+          <a:fontRef idx="minor">
+            <a:schemeClr val="lt1"/>
+          </a:fontRef>
+        </p:style>
+        <p:txBody>
+          <a:bodyPr rtlCol="0" anchor="ctr"/>
+          <a:lstStyle/>
+          <a:p>
+            <a:pPr algn="ctr"/>
+          </a:p>
+        </p:txBody>
+      </p:sp>
+      <p:sp>
+        <p:nvSpPr>
+          <p:cNvPr id="10" name="TextBox 9"/>
+          <p:cNvSpPr txBox="1"/>
+          <p:nvPr/>
+        </p:nvSpPr>
+        <p:spPr>
+          <a:xfrm>
+            <a:off x="7088886" y="2628899"/>
+            <a:ext cx="4450842" cy="384048"/>
+          </a:xfrm>
+          <a:prstGeom prst="rect">
+            <a:avLst/>
+          </a:prstGeom>
+          <a:noFill/>
+        </p:spPr>
+        <p:txBody>
+          <a:bodyPr wrap="square" anchor="t" lIns="0" rIns="0" tIns="0" bIns="0">
+            <a:spAutoFit/>
+          </a:bodyPr>
+          <a:lstStyle/>
+          <a:p>
+            <a:pPr algn="l"/>
+            <a:r>
+              <a:rPr sz="1400" b="1" i="0">
+                <a:solidFill>
+                  <a:srgbClr val="FF1493"/>
+                </a:solidFill>
+                <a:latin typeface="Geist Mono"/>
+              </a:rPr>
+              <a:t>WE GRADED ON</a:t>
+            </a:r>
+          </a:p>
+        </p:txBody>
+      </p:sp>
+      <p:sp>
+        <p:nvSpPr>
+          <p:cNvPr id="11" name="TextBox 10"/>
+          <p:cNvSpPr txBox="1"/>
+          <p:nvPr/>
+        </p:nvSpPr>
+        <p:spPr>
+          <a:xfrm>
+            <a:off x="7088886" y="3177539"/>
+            <a:ext cx="4450842" cy="1142999"/>
+          </a:xfrm>
+          <a:prstGeom prst="rect">
+            <a:avLst/>
+          </a:prstGeom>
+          <a:noFill/>
+        </p:spPr>
+        <p:txBody>
+          <a:bodyPr wrap="square" anchor="t" lIns="0" rIns="0" tIns="0" bIns="0">
+            <a:spAutoFit/>
+          </a:bodyPr>
+          <a:lstStyle/>
+          <a:p>
+            <a:pPr algn="l"/>
+            <a:r>
+              <a:rPr sz="1200" b="0" i="0">
+                <a:solidFill>
+                  <a:srgbClr val="14141C"/>
+                </a:solidFill>
+                <a:latin typeface="Geist"/>
+              </a:rPr>
+              <a:t>Melanoma recall -- the share of true melanomas actually caught. On this data that single number, not overall accuracy, is what decides whether the tool is safe.</a:t>
             </a:r>
           </a:p>
         </p:txBody>
@@ -9102,4 +12106,324 @@
   </a:objectDefaults>
   <a:extraClrSchemeLst/>
 </a:theme>
+</file>
+
+<file path=ppt/theme/theme2.xml><?xml version="1.0" encoding="utf-8"?>
+<a:theme xmlns:a="http://schemas.openxmlformats.org/drawingml/2006/main" name="Office Theme">
+  <a:themeElements>
+    <a:clrScheme name="Office">
+      <a:dk1>
+        <a:sysClr val="windowText" lastClr="000000"/>
+      </a:dk1>
+      <a:lt1>
+        <a:sysClr val="window" lastClr="FFFFFF"/>
+      </a:lt1>
+      <a:dk2>
+        <a:srgbClr val="1F497D"/>
+      </a:dk2>
+      <a:lt2>
+        <a:srgbClr val="EEECE1"/>
+      </a:lt2>
+      <a:accent1>
+        <a:srgbClr val="4F81BD"/>
+      </a:accent1>
+      <a:accent2>
+        <a:srgbClr val="C0504D"/>
+      </a:accent2>
+      <a:accent3>
+        <a:srgbClr val="9BBB59"/>
+      </a:accent3>
+      <a:accent4>
+        <a:srgbClr val="8064A2"/>
+      </a:accent4>
+      <a:accent5>
+        <a:srgbClr val="4BACC6"/>
+      </a:accent5>
+      <a:accent6>
+        <a:srgbClr val="F79646"/>
+      </a:accent6>
+      <a:hlink>
+        <a:srgbClr val="0000FF"/>
+      </a:hlink>
+      <a:folHlink>
+        <a:srgbClr val="800080"/>
+      </a:folHlink>
+    </a:clrScheme>
+    <a:fontScheme name="Office">
+      <a:majorFont>
+        <a:latin typeface="Calibri"/>
+        <a:ea typeface=""/>
+        <a:cs typeface=""/>
+        <a:font script="Jpan" typeface="ＭＳ Ｐゴシック"/>
+        <a:font script="Hang" typeface="맑은 고딕"/>
+        <a:font script="Hans" typeface="宋体"/>
+        <a:font script="Hant" typeface="新細明體"/>
+        <a:font script="Arab" typeface="Times New Roman"/>
+        <a:font script="Hebr" typeface="Times New Roman"/>
+        <a:font script="Thai" typeface="Angsana New"/>
+        <a:font script="Ethi" typeface="Nyala"/>
+        <a:font script="Beng" typeface="Vrinda"/>
+        <a:font script="Gujr" typeface="Shruti"/>
+        <a:font script="Khmr" typeface="MoolBoran"/>
+        <a:font script="Knda" typeface="Tunga"/>
+        <a:font script="Guru" typeface="Raavi"/>
+        <a:font script="Cans" typeface="Euphemia"/>
+        <a:font script="Cher" typeface="Plantagenet Cherokee"/>
+        <a:font script="Yiii" typeface="Microsoft Yi Baiti"/>
+        <a:font script="Tibt" typeface="Microsoft Himalaya"/>
+        <a:font script="Thaa" typeface="MV Boli"/>
+        <a:font script="Deva" typeface="Mangal"/>
+        <a:font script="Telu" typeface="Gautami"/>
+        <a:font script="Taml" typeface="Latha"/>
+        <a:font script="Syrc" typeface="Estrangelo Edessa"/>
+        <a:font script="Orya" typeface="Kalinga"/>
+        <a:font script="Mlym" typeface="Kartika"/>
+        <a:font script="Laoo" typeface="DokChampa"/>
+        <a:font script="Sinh" typeface="Iskoola Pota"/>
+        <a:font script="Mong" typeface="Mongolian Baiti"/>
+        <a:font script="Viet" typeface="Times New Roman"/>
+        <a:font script="Uigh" typeface="Microsoft Uighur"/>
+        <a:font script="Geor" typeface="Sylfaen"/>
+      </a:majorFont>
+      <a:minorFont>
+        <a:latin typeface="Calibri"/>
+        <a:ea typeface=""/>
+        <a:cs typeface=""/>
+        <a:font script="Jpan" typeface="ＭＳ Ｐゴシック"/>
+        <a:font script="Hang" typeface="맑은 고딕"/>
+        <a:font script="Hans" typeface="宋体"/>
+        <a:font script="Hant" typeface="新細明體"/>
+        <a:font script="Arab" typeface="Arial"/>
+        <a:font script="Hebr" typeface="Arial"/>
+        <a:font script="Thai" typeface="Cordia New"/>
+        <a:font script="Ethi" typeface="Nyala"/>
+        <a:font script="Beng" typeface="Vrinda"/>
+        <a:font script="Gujr" typeface="Shruti"/>
+        <a:font script="Khmr" typeface="DaunPenh"/>
+        <a:font script="Knda" typeface="Tunga"/>
+        <a:font script="Guru" typeface="Raavi"/>
+        <a:font script="Cans" typeface="Euphemia"/>
+        <a:font script="Cher" typeface="Plantagenet Cherokee"/>
+        <a:font script="Yiii" typeface="Microsoft Yi Baiti"/>
+        <a:font script="Tibt" typeface="Microsoft Himalaya"/>
+        <a:font script="Thaa" typeface="MV Boli"/>
+        <a:font script="Deva" typeface="Mangal"/>
+        <a:font script="Telu" typeface="Gautami"/>
+        <a:font script="Taml" typeface="Latha"/>
+        <a:font script="Syrc" typeface="Estrangelo Edessa"/>
+        <a:font script="Orya" typeface="Kalinga"/>
+        <a:font script="Mlym" typeface="Kartika"/>
+        <a:font script="Laoo" typeface="DokChampa"/>
+        <a:font script="Sinh" typeface="Iskoola Pota"/>
+        <a:font script="Mong" typeface="Mongolian Baiti"/>
+        <a:font script="Viet" typeface="Arial"/>
+        <a:font script="Uigh" typeface="Microsoft Uighur"/>
+        <a:font script="Geor" typeface="Sylfaen"/>
+      </a:minorFont>
+    </a:fontScheme>
+    <a:fmtScheme name="Office">
+      <a:fillStyleLst>
+        <a:solidFill>
+          <a:schemeClr val="phClr"/>
+        </a:solidFill>
+        <a:gradFill rotWithShape="1">
+          <a:gsLst>
+            <a:gs pos="0">
+              <a:schemeClr val="phClr">
+                <a:tint val="50000"/>
+                <a:satMod val="300000"/>
+              </a:schemeClr>
+            </a:gs>
+            <a:gs pos="35000">
+              <a:schemeClr val="phClr">
+                <a:tint val="37000"/>
+                <a:satMod val="300000"/>
+              </a:schemeClr>
+            </a:gs>
+            <a:gs pos="100000">
+              <a:schemeClr val="phClr">
+                <a:tint val="15000"/>
+                <a:satMod val="350000"/>
+              </a:schemeClr>
+            </a:gs>
+          </a:gsLst>
+          <a:lin ang="16200000" scaled="1"/>
+        </a:gradFill>
+        <a:gradFill rotWithShape="1">
+          <a:gsLst>
+            <a:gs pos="0">
+              <a:schemeClr val="phClr">
+                <a:tint val="100000"/>
+                <a:shade val="100000"/>
+                <a:satMod val="130000"/>
+              </a:schemeClr>
+            </a:gs>
+            <a:gs pos="100000">
+              <a:schemeClr val="phClr">
+                <a:tint val="50000"/>
+                <a:shade val="100000"/>
+                <a:satMod val="350000"/>
+              </a:schemeClr>
+            </a:gs>
+          </a:gsLst>
+          <a:lin ang="16200000" scaled="0"/>
+        </a:gradFill>
+      </a:fillStyleLst>
+      <a:lnStyleLst>
+        <a:ln w="9525" cap="flat" cmpd="sng" algn="ctr">
+          <a:solidFill>
+            <a:schemeClr val="phClr">
+              <a:shade val="95000"/>
+              <a:satMod val="105000"/>
+            </a:schemeClr>
+          </a:solidFill>
+          <a:prstDash val="solid"/>
+        </a:ln>
+        <a:ln w="25400" cap="flat" cmpd="sng" algn="ctr">
+          <a:solidFill>
+            <a:schemeClr val="phClr"/>
+          </a:solidFill>
+          <a:prstDash val="solid"/>
+        </a:ln>
+        <a:ln w="38100" cap="flat" cmpd="sng" algn="ctr">
+          <a:solidFill>
+            <a:schemeClr val="phClr"/>
+          </a:solidFill>
+          <a:prstDash val="solid"/>
+        </a:ln>
+      </a:lnStyleLst>
+      <a:effectStyleLst>
+        <a:effectStyle>
+          <a:effectLst>
+            <a:outerShdw blurRad="40000" dist="20000" dir="5400000" rotWithShape="0">
+              <a:srgbClr val="000000">
+                <a:alpha val="38000"/>
+              </a:srgbClr>
+            </a:outerShdw>
+          </a:effectLst>
+        </a:effectStyle>
+        <a:effectStyle>
+          <a:effectLst>
+            <a:outerShdw blurRad="40000" dist="23000" dir="5400000" rotWithShape="0">
+              <a:srgbClr val="000000">
+                <a:alpha val="35000"/>
+              </a:srgbClr>
+            </a:outerShdw>
+          </a:effectLst>
+        </a:effectStyle>
+        <a:effectStyle>
+          <a:effectLst>
+            <a:outerShdw blurRad="40000" dist="23000" dir="5400000" rotWithShape="0">
+              <a:srgbClr val="000000">
+                <a:alpha val="35000"/>
+              </a:srgbClr>
+            </a:outerShdw>
+          </a:effectLst>
+          <a:scene3d>
+            <a:camera prst="orthographicFront">
+              <a:rot lat="0" lon="0" rev="0"/>
+            </a:camera>
+            <a:lightRig rig="threePt" dir="t">
+              <a:rot lat="0" lon="0" rev="1200000"/>
+            </a:lightRig>
+          </a:scene3d>
+          <a:sp3d>
+            <a:bevelT w="63500" h="25400"/>
+          </a:sp3d>
+        </a:effectStyle>
+      </a:effectStyleLst>
+      <a:bgFillStyleLst>
+        <a:solidFill>
+          <a:schemeClr val="phClr"/>
+        </a:solidFill>
+        <a:gradFill rotWithShape="1">
+          <a:gsLst>
+            <a:gs pos="0">
+              <a:schemeClr val="phClr">
+                <a:tint val="40000"/>
+                <a:satMod val="350000"/>
+              </a:schemeClr>
+            </a:gs>
+            <a:gs pos="40000">
+              <a:schemeClr val="phClr">
+                <a:tint val="45000"/>
+                <a:shade val="99000"/>
+                <a:satMod val="350000"/>
+              </a:schemeClr>
+            </a:gs>
+            <a:gs pos="100000">
+              <a:schemeClr val="phClr">
+                <a:shade val="20000"/>
+                <a:satMod val="255000"/>
+              </a:schemeClr>
+            </a:gs>
+          </a:gsLst>
+          <a:path path="circle">
+            <a:fillToRect l="50000" t="-80000" r="50000" b="180000"/>
+          </a:path>
+        </a:gradFill>
+        <a:gradFill rotWithShape="1">
+          <a:gsLst>
+            <a:gs pos="0">
+              <a:schemeClr val="phClr">
+                <a:tint val="80000"/>
+                <a:satMod val="300000"/>
+              </a:schemeClr>
+            </a:gs>
+            <a:gs pos="100000">
+              <a:schemeClr val="phClr">
+                <a:shade val="30000"/>
+                <a:satMod val="200000"/>
+              </a:schemeClr>
+            </a:gs>
+          </a:gsLst>
+          <a:path path="circle">
+            <a:fillToRect l="50000" t="50000" r="50000" b="50000"/>
+          </a:path>
+        </a:gradFill>
+      </a:bgFillStyleLst>
+    </a:fmtScheme>
+  </a:themeElements>
+  <a:objectDefaults>
+    <a:spDef>
+      <a:spPr/>
+      <a:bodyPr/>
+      <a:lstStyle/>
+      <a:style>
+        <a:lnRef idx="1">
+          <a:schemeClr val="accent1"/>
+        </a:lnRef>
+        <a:fillRef idx="3">
+          <a:schemeClr val="accent1"/>
+        </a:fillRef>
+        <a:effectRef idx="2">
+          <a:schemeClr val="accent1"/>
+        </a:effectRef>
+        <a:fontRef idx="minor">
+          <a:schemeClr val="lt1"/>
+        </a:fontRef>
+      </a:style>
+    </a:spDef>
+    <a:lnDef>
+      <a:spPr/>
+      <a:bodyPr/>
+      <a:lstStyle/>
+      <a:style>
+        <a:lnRef idx="2">
+          <a:schemeClr val="accent1"/>
+        </a:lnRef>
+        <a:fillRef idx="0">
+          <a:schemeClr val="accent1"/>
+        </a:fillRef>
+        <a:effectRef idx="1">
+          <a:schemeClr val="accent1"/>
+        </a:effectRef>
+        <a:fontRef idx="minor">
+          <a:schemeClr val="tx1"/>
+        </a:fontRef>
+      </a:style>
+    </a:lnDef>
+  </a:objectDefaults>
+  <a:extraClrSchemeLst/>
+</a:theme>
 </file>
</xml_diff>